<commit_message>
fix: make patch-budget trends slide fully editable
</commit_message>
<xml_diff>
--- a/output/comparison/ST/andersson/patch_budget/presentation/01_patch_budget_trends.pptx
+++ b/output/comparison/ST/andersson/patch_budget/presentation/01_patch_budget_trends.pptx
@@ -105,6 +105,2486 @@
     </a:lvl9pPr>
   </p:defaultTextStyle>
 </p:presentation>
+</file>
+
+<file path=ppt/charts/chart1.xml><?xml version="1.0" encoding="utf-8"?>
+<c:chartSpace xmlns:c="http://schemas.openxmlformats.org/drawingml/2006/chart" xmlns:a="http://schemas.openxmlformats.org/drawingml/2006/main" xmlns:r="http://schemas.openxmlformats.org/officeDocument/2006/relationships">
+  <c:date1904 val="0"/>
+  <c:style val="10"/>
+  <c:chart>
+    <c:autoTitleDeleted val="1"/>
+    <c:plotArea>
+      <c:lineChart>
+        <c:grouping val="standard"/>
+        <c:varyColors val="0"/>
+        <c:ser>
+          <c:idx val="0"/>
+          <c:order val="0"/>
+          <c:tx>
+            <c:strRef>
+              <c:f>Sheet1!$B$1</c:f>
+              <c:strCache>
+                <c:ptCount val="1"/>
+                <c:pt idx="0">
+                  <c:v>Random</c:v>
+                </c:pt>
+              </c:strCache>
+            </c:strRef>
+          </c:tx>
+          <c:spPr>
+            <a:ln w="25400">
+              <a:solidFill>
+                <a:srgbClr val="49A6FF"/>
+              </a:solidFill>
+            </a:ln>
+          </c:spPr>
+          <c:marker>
+            <c:symbol val="circle"/>
+            <c:size val="6"/>
+            <c:spPr>
+              <a:solidFill>
+                <a:srgbClr val="49A6FF"/>
+              </a:solidFill>
+              <a:ln>
+                <a:solidFill>
+                  <a:srgbClr val="49A6FF"/>
+                </a:solidFill>
+              </a:ln>
+            </c:spPr>
+          </c:marker>
+          <c:cat>
+            <c:strRef>
+              <c:f>Sheet1!$A$2:$A$6</c:f>
+              <c:strCache>
+                <c:ptCount val="5"/>
+                <c:pt idx="0">
+                  <c:v>5</c:v>
+                </c:pt>
+                <c:pt idx="1">
+                  <c:v>10</c:v>
+                </c:pt>
+                <c:pt idx="2">
+                  <c:v>15</c:v>
+                </c:pt>
+                <c:pt idx="3">
+                  <c:v>20</c:v>
+                </c:pt>
+                <c:pt idx="4">
+                  <c:v>25 Baseline</c:v>
+                </c:pt>
+              </c:strCache>
+            </c:strRef>
+          </c:cat>
+          <c:val>
+            <c:numRef>
+              <c:f>Sheet1!$B$2:$B$6</c:f>
+              <c:numCache>
+                <c:formatCode>General</c:formatCode>
+                <c:ptCount val="5"/>
+                <c:pt idx="0">
+                  <c:v>7.506315300515966</c:v>
+                </c:pt>
+                <c:pt idx="1">
+                  <c:v>5.379947493324251</c:v>
+                </c:pt>
+                <c:pt idx="2">
+                  <c:v>0.1988053220514115</c:v>
+                </c:pt>
+                <c:pt idx="3">
+                  <c:v>0.2939049441717196</c:v>
+                </c:pt>
+              </c:numCache>
+            </c:numRef>
+          </c:val>
+          <c:smooth val="0"/>
+        </c:ser>
+        <c:ser>
+          <c:idx val="1"/>
+          <c:order val="1"/>
+          <c:tx>
+            <c:strRef>
+              <c:f>Sheet1!$C$1</c:f>
+              <c:strCache>
+                <c:ptCount val="1"/>
+                <c:pt idx="0">
+                  <c:v>Similarity</c:v>
+                </c:pt>
+              </c:strCache>
+            </c:strRef>
+          </c:tx>
+          <c:spPr>
+            <a:ln w="25400">
+              <a:solidFill>
+                <a:srgbClr val="33D6B4"/>
+              </a:solidFill>
+            </a:ln>
+          </c:spPr>
+          <c:marker>
+            <c:symbol val="circle"/>
+            <c:size val="6"/>
+            <c:spPr>
+              <a:solidFill>
+                <a:srgbClr val="33D6B4"/>
+              </a:solidFill>
+              <a:ln>
+                <a:solidFill>
+                  <a:srgbClr val="33D6B4"/>
+                </a:solidFill>
+              </a:ln>
+            </c:spPr>
+          </c:marker>
+          <c:cat>
+            <c:strRef>
+              <c:f>Sheet1!$A$2:$A$6</c:f>
+              <c:strCache>
+                <c:ptCount val="5"/>
+                <c:pt idx="0">
+                  <c:v>5</c:v>
+                </c:pt>
+                <c:pt idx="1">
+                  <c:v>10</c:v>
+                </c:pt>
+                <c:pt idx="2">
+                  <c:v>15</c:v>
+                </c:pt>
+                <c:pt idx="3">
+                  <c:v>20</c:v>
+                </c:pt>
+                <c:pt idx="4">
+                  <c:v>25 Baseline</c:v>
+                </c:pt>
+              </c:strCache>
+            </c:strRef>
+          </c:cat>
+          <c:val>
+            <c:numRef>
+              <c:f>Sheet1!$C$2:$C$6</c:f>
+              <c:numCache>
+                <c:formatCode>General</c:formatCode>
+                <c:ptCount val="5"/>
+                <c:pt idx="0">
+                  <c:v>7.282333775183789</c:v>
+                </c:pt>
+                <c:pt idx="1">
+                  <c:v>7.545802832650388</c:v>
+                </c:pt>
+                <c:pt idx="2">
+                  <c:v>2.026114309260857</c:v>
+                </c:pt>
+                <c:pt idx="3">
+                  <c:v>-1.8729005736525015</c:v>
+                </c:pt>
+              </c:numCache>
+            </c:numRef>
+          </c:val>
+          <c:smooth val="0"/>
+        </c:ser>
+        <c:ser>
+          <c:idx val="2"/>
+          <c:order val="2"/>
+          <c:tx>
+            <c:strRef>
+              <c:f>Sheet1!$D$1</c:f>
+              <c:strCache>
+                <c:ptCount val="1"/>
+                <c:pt idx="0">
+                  <c:v>Diversity</c:v>
+                </c:pt>
+              </c:strCache>
+            </c:strRef>
+          </c:tx>
+          <c:spPr>
+            <a:ln w="25400">
+              <a:solidFill>
+                <a:srgbClr val="B58CFF"/>
+              </a:solidFill>
+            </a:ln>
+          </c:spPr>
+          <c:marker>
+            <c:symbol val="circle"/>
+            <c:size val="6"/>
+            <c:spPr>
+              <a:solidFill>
+                <a:srgbClr val="B58CFF"/>
+              </a:solidFill>
+              <a:ln>
+                <a:solidFill>
+                  <a:srgbClr val="B58CFF"/>
+                </a:solidFill>
+              </a:ln>
+            </c:spPr>
+          </c:marker>
+          <c:cat>
+            <c:strRef>
+              <c:f>Sheet1!$A$2:$A$6</c:f>
+              <c:strCache>
+                <c:ptCount val="5"/>
+                <c:pt idx="0">
+                  <c:v>5</c:v>
+                </c:pt>
+                <c:pt idx="1">
+                  <c:v>10</c:v>
+                </c:pt>
+                <c:pt idx="2">
+                  <c:v>15</c:v>
+                </c:pt>
+                <c:pt idx="3">
+                  <c:v>20</c:v>
+                </c:pt>
+                <c:pt idx="4">
+                  <c:v>25 Baseline</c:v>
+                </c:pt>
+              </c:strCache>
+            </c:strRef>
+          </c:cat>
+          <c:val>
+            <c:numRef>
+              <c:f>Sheet1!$D$2:$D$6</c:f>
+              <c:numCache>
+                <c:formatCode>General</c:formatCode>
+                <c:ptCount val="5"/>
+                <c:pt idx="0">
+                  <c:v>0.56157730707059</c:v>
+                </c:pt>
+                <c:pt idx="1">
+                  <c:v>4.358560471006176</c:v>
+                </c:pt>
+                <c:pt idx="2">
+                  <c:v>3.93845199314773</c:v>
+                </c:pt>
+                <c:pt idx="3">
+                  <c:v>3.05216104664453</c:v>
+                </c:pt>
+              </c:numCache>
+            </c:numRef>
+          </c:val>
+          <c:smooth val="0"/>
+        </c:ser>
+        <c:ser>
+          <c:idx val="3"/>
+          <c:order val="3"/>
+          <c:tx>
+            <c:strRef>
+              <c:f>Sheet1!$E$1</c:f>
+              <c:strCache>
+                <c:ptCount val="1"/>
+                <c:pt idx="0">
+                  <c:v>ST Hard</c:v>
+                </c:pt>
+              </c:strCache>
+            </c:strRef>
+          </c:tx>
+          <c:spPr>
+            <a:ln w="25400">
+              <a:solidFill>
+                <a:srgbClr val="FF8A65"/>
+              </a:solidFill>
+            </a:ln>
+          </c:spPr>
+          <c:marker>
+            <c:symbol val="circle"/>
+            <c:size val="6"/>
+            <c:spPr>
+              <a:solidFill>
+                <a:srgbClr val="FF8A65"/>
+              </a:solidFill>
+              <a:ln>
+                <a:solidFill>
+                  <a:srgbClr val="FF8A65"/>
+                </a:solidFill>
+              </a:ln>
+            </c:spPr>
+          </c:marker>
+          <c:cat>
+            <c:strRef>
+              <c:f>Sheet1!$A$2:$A$6</c:f>
+              <c:strCache>
+                <c:ptCount val="5"/>
+                <c:pt idx="0">
+                  <c:v>5</c:v>
+                </c:pt>
+                <c:pt idx="1">
+                  <c:v>10</c:v>
+                </c:pt>
+                <c:pt idx="2">
+                  <c:v>15</c:v>
+                </c:pt>
+                <c:pt idx="3">
+                  <c:v>20</c:v>
+                </c:pt>
+                <c:pt idx="4">
+                  <c:v>25 Baseline</c:v>
+                </c:pt>
+              </c:strCache>
+            </c:strRef>
+          </c:cat>
+          <c:val>
+            <c:numRef>
+              <c:f>Sheet1!$E$2:$E$6</c:f>
+              <c:numCache>
+                <c:formatCode>General</c:formatCode>
+                <c:ptCount val="5"/>
+                <c:pt idx="0">
+                  <c:v>6.012839785297185</c:v>
+                </c:pt>
+                <c:pt idx="1">
+                  <c:v>1.3966448282843398</c:v>
+                </c:pt>
+                <c:pt idx="2">
+                  <c:v>-1.7250286856523955</c:v>
+                </c:pt>
+                <c:pt idx="3">
+                  <c:v>-1.1236910979316292</c:v>
+                </c:pt>
+              </c:numCache>
+            </c:numRef>
+          </c:val>
+          <c:smooth val="0"/>
+        </c:ser>
+        <c:ser>
+          <c:idx val="4"/>
+          <c:order val="4"/>
+          <c:tx>
+            <c:strRef>
+              <c:f>Sheet1!$F$1</c:f>
+              <c:strCache>
+                <c:ptCount val="1"/>
+                <c:pt idx="0">
+                  <c:v>Baseline-25</c:v>
+                </c:pt>
+              </c:strCache>
+            </c:strRef>
+          </c:tx>
+          <c:spPr>
+            <a:ln>
+              <a:solidFill>
+                <a:srgbClr val="F5C451"/>
+              </a:solidFill>
+            </a:ln>
+          </c:spPr>
+          <c:marker>
+            <c:symbol val="star"/>
+            <c:size val="11"/>
+            <c:spPr>
+              <a:solidFill>
+                <a:srgbClr val="F5C451"/>
+              </a:solidFill>
+              <a:ln>
+                <a:solidFill>
+                  <a:srgbClr val="B98918"/>
+                </a:solidFill>
+              </a:ln>
+            </c:spPr>
+          </c:marker>
+          <c:cat>
+            <c:strRef>
+              <c:f>Sheet1!$A$2:$A$6</c:f>
+              <c:strCache>
+                <c:ptCount val="5"/>
+                <c:pt idx="0">
+                  <c:v>5</c:v>
+                </c:pt>
+                <c:pt idx="1">
+                  <c:v>10</c:v>
+                </c:pt>
+                <c:pt idx="2">
+                  <c:v>15</c:v>
+                </c:pt>
+                <c:pt idx="3">
+                  <c:v>20</c:v>
+                </c:pt>
+                <c:pt idx="4">
+                  <c:v>25 Baseline</c:v>
+                </c:pt>
+              </c:strCache>
+            </c:strRef>
+          </c:cat>
+          <c:val>
+            <c:numRef>
+              <c:f>Sheet1!$F$2:$F$6</c:f>
+              <c:numCache>
+                <c:formatCode>General</c:formatCode>
+                <c:ptCount val="5"/>
+                <c:pt idx="4">
+                  <c:v>0.0</c:v>
+                </c:pt>
+              </c:numCache>
+            </c:numRef>
+          </c:val>
+          <c:smooth val="0"/>
+        </c:ser>
+        <c:marker val="1"/>
+        <c:smooth val="0"/>
+        <c:axId val="2118791784"/>
+        <c:axId val="2140495176"/>
+      </c:lineChart>
+      <c:catAx>
+        <c:axId val="2118791784"/>
+        <c:scaling>
+          <c:orientation val="minMax"/>
+        </c:scaling>
+        <c:delete val="0"/>
+        <c:axPos val="b"/>
+        <c:majorTickMark val="out"/>
+        <c:minorTickMark val="none"/>
+        <c:tickLblPos val="nextTo"/>
+        <c:txPr>
+          <a:bodyPr/>
+          <a:lstStyle/>
+          <a:p>
+            <a:pPr>
+              <a:defRPr sz="800">
+                <a:latin typeface="Arial"/>
+              </a:defRPr>
+            </a:pPr>
+          </a:p>
+        </c:txPr>
+        <c:crossAx val="2140495176"/>
+        <c:crosses val="autoZero"/>
+        <c:auto val="1"/>
+        <c:lblAlgn val="ctr"/>
+        <c:lblOffset val="100"/>
+        <c:noMultiLvlLbl val="0"/>
+      </c:catAx>
+      <c:valAx>
+        <c:axId val="2140495176"/>
+        <c:scaling>
+          <c:max val="9.0"/>
+          <c:min val="-9.0"/>
+        </c:scaling>
+        <c:delete val="0"/>
+        <c:axPos val="l"/>
+        <c:majorGridlines>
+          <c:spPr>
+            <a:ln>
+              <a:solidFill>
+                <a:srgbClr val="D8E0E8"/>
+              </a:solidFill>
+            </a:ln>
+          </c:spPr>
+        </c:majorGridlines>
+        <c:numFmt formatCode="0.0&quot;%&quot;" sourceLinked="0"/>
+        <c:majorTickMark val="out"/>
+        <c:minorTickMark val="none"/>
+        <c:tickLblPos val="nextTo"/>
+        <c:txPr>
+          <a:bodyPr/>
+          <a:lstStyle/>
+          <a:p>
+            <a:pPr>
+              <a:defRPr sz="800">
+                <a:latin typeface="Arial"/>
+              </a:defRPr>
+            </a:pPr>
+          </a:p>
+        </c:txPr>
+        <c:crossAx val="2118791784"/>
+        <c:crosses val="autoZero"/>
+        <c:majorUnit val="4.5"/>
+      </c:valAx>
+    </c:plotArea>
+    <c:plotVisOnly val="1"/>
+    <c:dispBlanksAs val="gap"/>
+    <c:showDLblsOverMax val="0"/>
+  </c:chart>
+  <c:txPr>
+    <a:bodyPr/>
+    <a:lstStyle/>
+    <a:p>
+      <a:pPr>
+        <a:defRPr sz="1800"/>
+      </a:pPr>
+      <a:endParaRPr lang="en-US"/>
+    </a:p>
+  </c:txPr>
+  <c:externalData r:id="rId1">
+    <c:autoUpdate val="0"/>
+  </c:externalData>
+</c:chartSpace>
+</file>
+
+<file path=ppt/charts/chart2.xml><?xml version="1.0" encoding="utf-8"?>
+<c:chartSpace xmlns:c="http://schemas.openxmlformats.org/drawingml/2006/chart" xmlns:a="http://schemas.openxmlformats.org/drawingml/2006/main" xmlns:r="http://schemas.openxmlformats.org/officeDocument/2006/relationships">
+  <c:date1904 val="0"/>
+  <c:style val="10"/>
+  <c:chart>
+    <c:autoTitleDeleted val="1"/>
+    <c:plotArea>
+      <c:lineChart>
+        <c:grouping val="standard"/>
+        <c:varyColors val="0"/>
+        <c:ser>
+          <c:idx val="0"/>
+          <c:order val="0"/>
+          <c:tx>
+            <c:strRef>
+              <c:f>Sheet1!$B$1</c:f>
+              <c:strCache>
+                <c:ptCount val="1"/>
+                <c:pt idx="0">
+                  <c:v>Random</c:v>
+                </c:pt>
+              </c:strCache>
+            </c:strRef>
+          </c:tx>
+          <c:spPr>
+            <a:ln w="25400">
+              <a:solidFill>
+                <a:srgbClr val="49A6FF"/>
+              </a:solidFill>
+            </a:ln>
+          </c:spPr>
+          <c:marker>
+            <c:symbol val="circle"/>
+            <c:size val="6"/>
+            <c:spPr>
+              <a:solidFill>
+                <a:srgbClr val="49A6FF"/>
+              </a:solidFill>
+              <a:ln>
+                <a:solidFill>
+                  <a:srgbClr val="49A6FF"/>
+                </a:solidFill>
+              </a:ln>
+            </c:spPr>
+          </c:marker>
+          <c:cat>
+            <c:strRef>
+              <c:f>Sheet1!$A$2:$A$6</c:f>
+              <c:strCache>
+                <c:ptCount val="5"/>
+                <c:pt idx="0">
+                  <c:v>5</c:v>
+                </c:pt>
+                <c:pt idx="1">
+                  <c:v>10</c:v>
+                </c:pt>
+                <c:pt idx="2">
+                  <c:v>15</c:v>
+                </c:pt>
+                <c:pt idx="3">
+                  <c:v>20</c:v>
+                </c:pt>
+                <c:pt idx="4">
+                  <c:v>25 Baseline</c:v>
+                </c:pt>
+              </c:strCache>
+            </c:strRef>
+          </c:cat>
+          <c:val>
+            <c:numRef>
+              <c:f>Sheet1!$B$2:$B$6</c:f>
+              <c:numCache>
+                <c:formatCode>General</c:formatCode>
+                <c:ptCount val="5"/>
+                <c:pt idx="0">
+                  <c:v>2.575961564828404</c:v>
+                </c:pt>
+                <c:pt idx="1">
+                  <c:v>1.7400148515265883</c:v>
+                </c:pt>
+                <c:pt idx="2">
+                  <c:v>0.6030456410493135</c:v>
+                </c:pt>
+                <c:pt idx="3">
+                  <c:v>0.20457051154990144</c:v>
+                </c:pt>
+              </c:numCache>
+            </c:numRef>
+          </c:val>
+          <c:smooth val="0"/>
+        </c:ser>
+        <c:ser>
+          <c:idx val="1"/>
+          <c:order val="1"/>
+          <c:tx>
+            <c:strRef>
+              <c:f>Sheet1!$C$1</c:f>
+              <c:strCache>
+                <c:ptCount val="1"/>
+                <c:pt idx="0">
+                  <c:v>Similarity</c:v>
+                </c:pt>
+              </c:strCache>
+            </c:strRef>
+          </c:tx>
+          <c:spPr>
+            <a:ln w="25400">
+              <a:solidFill>
+                <a:srgbClr val="33D6B4"/>
+              </a:solidFill>
+            </a:ln>
+          </c:spPr>
+          <c:marker>
+            <c:symbol val="circle"/>
+            <c:size val="6"/>
+            <c:spPr>
+              <a:solidFill>
+                <a:srgbClr val="33D6B4"/>
+              </a:solidFill>
+              <a:ln>
+                <a:solidFill>
+                  <a:srgbClr val="33D6B4"/>
+                </a:solidFill>
+              </a:ln>
+            </c:spPr>
+          </c:marker>
+          <c:cat>
+            <c:strRef>
+              <c:f>Sheet1!$A$2:$A$6</c:f>
+              <c:strCache>
+                <c:ptCount val="5"/>
+                <c:pt idx="0">
+                  <c:v>5</c:v>
+                </c:pt>
+                <c:pt idx="1">
+                  <c:v>10</c:v>
+                </c:pt>
+                <c:pt idx="2">
+                  <c:v>15</c:v>
+                </c:pt>
+                <c:pt idx="3">
+                  <c:v>20</c:v>
+                </c:pt>
+                <c:pt idx="4">
+                  <c:v>25 Baseline</c:v>
+                </c:pt>
+              </c:strCache>
+            </c:strRef>
+          </c:cat>
+          <c:val>
+            <c:numRef>
+              <c:f>Sheet1!$C$2:$C$6</c:f>
+              <c:numCache>
+                <c:formatCode>General</c:formatCode>
+                <c:ptCount val="5"/>
+                <c:pt idx="0">
+                  <c:v>2.414082952044603</c:v>
+                </c:pt>
+                <c:pt idx="1">
+                  <c:v>0.875319350574035</c:v>
+                </c:pt>
+                <c:pt idx="2">
+                  <c:v>0.07816949331729989</c:v>
+                </c:pt>
+                <c:pt idx="3">
+                  <c:v>-1.5005031380829381</c:v>
+                </c:pt>
+              </c:numCache>
+            </c:numRef>
+          </c:val>
+          <c:smooth val="0"/>
+        </c:ser>
+        <c:ser>
+          <c:idx val="2"/>
+          <c:order val="2"/>
+          <c:tx>
+            <c:strRef>
+              <c:f>Sheet1!$D$1</c:f>
+              <c:strCache>
+                <c:ptCount val="1"/>
+                <c:pt idx="0">
+                  <c:v>Diversity</c:v>
+                </c:pt>
+              </c:strCache>
+            </c:strRef>
+          </c:tx>
+          <c:spPr>
+            <a:ln w="25400">
+              <a:solidFill>
+                <a:srgbClr val="B58CFF"/>
+              </a:solidFill>
+            </a:ln>
+          </c:spPr>
+          <c:marker>
+            <c:symbol val="circle"/>
+            <c:size val="6"/>
+            <c:spPr>
+              <a:solidFill>
+                <a:srgbClr val="B58CFF"/>
+              </a:solidFill>
+              <a:ln>
+                <a:solidFill>
+                  <a:srgbClr val="B58CFF"/>
+                </a:solidFill>
+              </a:ln>
+            </c:spPr>
+          </c:marker>
+          <c:cat>
+            <c:strRef>
+              <c:f>Sheet1!$A$2:$A$6</c:f>
+              <c:strCache>
+                <c:ptCount val="5"/>
+                <c:pt idx="0">
+                  <c:v>5</c:v>
+                </c:pt>
+                <c:pt idx="1">
+                  <c:v>10</c:v>
+                </c:pt>
+                <c:pt idx="2">
+                  <c:v>15</c:v>
+                </c:pt>
+                <c:pt idx="3">
+                  <c:v>20</c:v>
+                </c:pt>
+                <c:pt idx="4">
+                  <c:v>25 Baseline</c:v>
+                </c:pt>
+              </c:strCache>
+            </c:strRef>
+          </c:cat>
+          <c:val>
+            <c:numRef>
+              <c:f>Sheet1!$D$2:$D$6</c:f>
+              <c:numCache>
+                <c:formatCode>General</c:formatCode>
+                <c:ptCount val="5"/>
+                <c:pt idx="0">
+                  <c:v>1.3411843397632315</c:v>
+                </c:pt>
+                <c:pt idx="1">
+                  <c:v>1.8844328211479768</c:v>
+                </c:pt>
+                <c:pt idx="2">
+                  <c:v>1.124094458994822</c:v>
+                </c:pt>
+                <c:pt idx="3">
+                  <c:v>0.5962504489190662</c:v>
+                </c:pt>
+              </c:numCache>
+            </c:numRef>
+          </c:val>
+          <c:smooth val="0"/>
+        </c:ser>
+        <c:ser>
+          <c:idx val="3"/>
+          <c:order val="3"/>
+          <c:tx>
+            <c:strRef>
+              <c:f>Sheet1!$E$1</c:f>
+              <c:strCache>
+                <c:ptCount val="1"/>
+                <c:pt idx="0">
+                  <c:v>ST Hard</c:v>
+                </c:pt>
+              </c:strCache>
+            </c:strRef>
+          </c:tx>
+          <c:spPr>
+            <a:ln w="25400">
+              <a:solidFill>
+                <a:srgbClr val="FF8A65"/>
+              </a:solidFill>
+            </a:ln>
+          </c:spPr>
+          <c:marker>
+            <c:symbol val="circle"/>
+            <c:size val="6"/>
+            <c:spPr>
+              <a:solidFill>
+                <a:srgbClr val="FF8A65"/>
+              </a:solidFill>
+              <a:ln>
+                <a:solidFill>
+                  <a:srgbClr val="FF8A65"/>
+                </a:solidFill>
+              </a:ln>
+            </c:spPr>
+          </c:marker>
+          <c:cat>
+            <c:strRef>
+              <c:f>Sheet1!$A$2:$A$6</c:f>
+              <c:strCache>
+                <c:ptCount val="5"/>
+                <c:pt idx="0">
+                  <c:v>5</c:v>
+                </c:pt>
+                <c:pt idx="1">
+                  <c:v>10</c:v>
+                </c:pt>
+                <c:pt idx="2">
+                  <c:v>15</c:v>
+                </c:pt>
+                <c:pt idx="3">
+                  <c:v>20</c:v>
+                </c:pt>
+                <c:pt idx="4">
+                  <c:v>25 Baseline</c:v>
+                </c:pt>
+              </c:strCache>
+            </c:strRef>
+          </c:cat>
+          <c:val>
+            <c:numRef>
+              <c:f>Sheet1!$E$2:$E$6</c:f>
+              <c:numCache>
+                <c:formatCode>General</c:formatCode>
+                <c:ptCount val="5"/>
+                <c:pt idx="0">
+                  <c:v>3.233096120909208</c:v>
+                </c:pt>
+                <c:pt idx="1">
+                  <c:v>0.9864862862542799</c:v>
+                </c:pt>
+                <c:pt idx="2">
+                  <c:v>-0.14765756883941655</c:v>
+                </c:pt>
+                <c:pt idx="3">
+                  <c:v>-0.9383994811401116</c:v>
+                </c:pt>
+              </c:numCache>
+            </c:numRef>
+          </c:val>
+          <c:smooth val="0"/>
+        </c:ser>
+        <c:ser>
+          <c:idx val="4"/>
+          <c:order val="4"/>
+          <c:tx>
+            <c:strRef>
+              <c:f>Sheet1!$F$1</c:f>
+              <c:strCache>
+                <c:ptCount val="1"/>
+                <c:pt idx="0">
+                  <c:v>Baseline-25</c:v>
+                </c:pt>
+              </c:strCache>
+            </c:strRef>
+          </c:tx>
+          <c:spPr>
+            <a:ln>
+              <a:solidFill>
+                <a:srgbClr val="F5C451"/>
+              </a:solidFill>
+            </a:ln>
+          </c:spPr>
+          <c:marker>
+            <c:symbol val="star"/>
+            <c:size val="11"/>
+            <c:spPr>
+              <a:solidFill>
+                <a:srgbClr val="F5C451"/>
+              </a:solidFill>
+              <a:ln>
+                <a:solidFill>
+                  <a:srgbClr val="B98918"/>
+                </a:solidFill>
+              </a:ln>
+            </c:spPr>
+          </c:marker>
+          <c:cat>
+            <c:strRef>
+              <c:f>Sheet1!$A$2:$A$6</c:f>
+              <c:strCache>
+                <c:ptCount val="5"/>
+                <c:pt idx="0">
+                  <c:v>5</c:v>
+                </c:pt>
+                <c:pt idx="1">
+                  <c:v>10</c:v>
+                </c:pt>
+                <c:pt idx="2">
+                  <c:v>15</c:v>
+                </c:pt>
+                <c:pt idx="3">
+                  <c:v>20</c:v>
+                </c:pt>
+                <c:pt idx="4">
+                  <c:v>25 Baseline</c:v>
+                </c:pt>
+              </c:strCache>
+            </c:strRef>
+          </c:cat>
+          <c:val>
+            <c:numRef>
+              <c:f>Sheet1!$F$2:$F$6</c:f>
+              <c:numCache>
+                <c:formatCode>General</c:formatCode>
+                <c:ptCount val="5"/>
+                <c:pt idx="4">
+                  <c:v>0.0</c:v>
+                </c:pt>
+              </c:numCache>
+            </c:numRef>
+          </c:val>
+          <c:smooth val="0"/>
+        </c:ser>
+        <c:marker val="1"/>
+        <c:smooth val="0"/>
+        <c:axId val="2118791784"/>
+        <c:axId val="2140495176"/>
+      </c:lineChart>
+      <c:catAx>
+        <c:axId val="2118791784"/>
+        <c:scaling>
+          <c:orientation val="minMax"/>
+        </c:scaling>
+        <c:delete val="0"/>
+        <c:axPos val="b"/>
+        <c:majorTickMark val="out"/>
+        <c:minorTickMark val="none"/>
+        <c:tickLblPos val="nextTo"/>
+        <c:txPr>
+          <a:bodyPr/>
+          <a:lstStyle/>
+          <a:p>
+            <a:pPr>
+              <a:defRPr sz="800">
+                <a:latin typeface="Arial"/>
+              </a:defRPr>
+            </a:pPr>
+          </a:p>
+        </c:txPr>
+        <c:crossAx val="2140495176"/>
+        <c:crosses val="autoZero"/>
+        <c:auto val="1"/>
+        <c:lblAlgn val="ctr"/>
+        <c:lblOffset val="100"/>
+        <c:noMultiLvlLbl val="0"/>
+      </c:catAx>
+      <c:valAx>
+        <c:axId val="2140495176"/>
+        <c:scaling>
+          <c:max val="9.0"/>
+          <c:min val="-9.0"/>
+        </c:scaling>
+        <c:delete val="0"/>
+        <c:axPos val="l"/>
+        <c:majorGridlines>
+          <c:spPr>
+            <a:ln>
+              <a:solidFill>
+                <a:srgbClr val="D8E0E8"/>
+              </a:solidFill>
+            </a:ln>
+          </c:spPr>
+        </c:majorGridlines>
+        <c:numFmt formatCode="0.0&quot;%&quot;" sourceLinked="0"/>
+        <c:majorTickMark val="out"/>
+        <c:minorTickMark val="none"/>
+        <c:tickLblPos val="nextTo"/>
+        <c:txPr>
+          <a:bodyPr/>
+          <a:lstStyle/>
+          <a:p>
+            <a:pPr>
+              <a:defRPr sz="800">
+                <a:latin typeface="Arial"/>
+              </a:defRPr>
+            </a:pPr>
+          </a:p>
+        </c:txPr>
+        <c:crossAx val="2118791784"/>
+        <c:crosses val="autoZero"/>
+        <c:majorUnit val="4.5"/>
+      </c:valAx>
+    </c:plotArea>
+    <c:plotVisOnly val="1"/>
+    <c:dispBlanksAs val="gap"/>
+    <c:showDLblsOverMax val="0"/>
+  </c:chart>
+  <c:txPr>
+    <a:bodyPr/>
+    <a:lstStyle/>
+    <a:p>
+      <a:pPr>
+        <a:defRPr sz="1800"/>
+      </a:pPr>
+      <a:endParaRPr lang="en-US"/>
+    </a:p>
+  </c:txPr>
+  <c:externalData r:id="rId1">
+    <c:autoUpdate val="0"/>
+  </c:externalData>
+</c:chartSpace>
+</file>
+
+<file path=ppt/charts/chart3.xml><?xml version="1.0" encoding="utf-8"?>
+<c:chartSpace xmlns:c="http://schemas.openxmlformats.org/drawingml/2006/chart" xmlns:a="http://schemas.openxmlformats.org/drawingml/2006/main" xmlns:r="http://schemas.openxmlformats.org/officeDocument/2006/relationships">
+  <c:date1904 val="0"/>
+  <c:style val="10"/>
+  <c:chart>
+    <c:autoTitleDeleted val="1"/>
+    <c:plotArea>
+      <c:lineChart>
+        <c:grouping val="standard"/>
+        <c:varyColors val="0"/>
+        <c:ser>
+          <c:idx val="0"/>
+          <c:order val="0"/>
+          <c:tx>
+            <c:strRef>
+              <c:f>Sheet1!$B$1</c:f>
+              <c:strCache>
+                <c:ptCount val="1"/>
+                <c:pt idx="0">
+                  <c:v>Random</c:v>
+                </c:pt>
+              </c:strCache>
+            </c:strRef>
+          </c:tx>
+          <c:spPr>
+            <a:ln w="25400">
+              <a:solidFill>
+                <a:srgbClr val="49A6FF"/>
+              </a:solidFill>
+            </a:ln>
+          </c:spPr>
+          <c:marker>
+            <c:symbol val="circle"/>
+            <c:size val="6"/>
+            <c:spPr>
+              <a:solidFill>
+                <a:srgbClr val="49A6FF"/>
+              </a:solidFill>
+              <a:ln>
+                <a:solidFill>
+                  <a:srgbClr val="49A6FF"/>
+                </a:solidFill>
+              </a:ln>
+            </c:spPr>
+          </c:marker>
+          <c:cat>
+            <c:strRef>
+              <c:f>Sheet1!$A$2:$A$6</c:f>
+              <c:strCache>
+                <c:ptCount val="5"/>
+                <c:pt idx="0">
+                  <c:v>5</c:v>
+                </c:pt>
+                <c:pt idx="1">
+                  <c:v>10</c:v>
+                </c:pt>
+                <c:pt idx="2">
+                  <c:v>15</c:v>
+                </c:pt>
+                <c:pt idx="3">
+                  <c:v>20</c:v>
+                </c:pt>
+                <c:pt idx="4">
+                  <c:v>25 Baseline</c:v>
+                </c:pt>
+              </c:strCache>
+            </c:strRef>
+          </c:cat>
+          <c:val>
+            <c:numRef>
+              <c:f>Sheet1!$B$2:$B$6</c:f>
+              <c:numCache>
+                <c:formatCode>General</c:formatCode>
+                <c:ptCount val="5"/>
+                <c:pt idx="0">
+                  <c:v>0.13784752860724814</c:v>
+                </c:pt>
+                <c:pt idx="1">
+                  <c:v>-0.1284085966133149</c:v>
+                </c:pt>
+                <c:pt idx="2">
+                  <c:v>1.1067157717431266</c:v>
+                </c:pt>
+                <c:pt idx="3">
+                  <c:v>0.45491929197995745</c:v>
+                </c:pt>
+              </c:numCache>
+            </c:numRef>
+          </c:val>
+          <c:smooth val="0"/>
+        </c:ser>
+        <c:ser>
+          <c:idx val="1"/>
+          <c:order val="1"/>
+          <c:tx>
+            <c:strRef>
+              <c:f>Sheet1!$C$1</c:f>
+              <c:strCache>
+                <c:ptCount val="1"/>
+                <c:pt idx="0">
+                  <c:v>Similarity</c:v>
+                </c:pt>
+              </c:strCache>
+            </c:strRef>
+          </c:tx>
+          <c:spPr>
+            <a:ln w="25400">
+              <a:solidFill>
+                <a:srgbClr val="33D6B4"/>
+              </a:solidFill>
+            </a:ln>
+          </c:spPr>
+          <c:marker>
+            <c:symbol val="circle"/>
+            <c:size val="6"/>
+            <c:spPr>
+              <a:solidFill>
+                <a:srgbClr val="33D6B4"/>
+              </a:solidFill>
+              <a:ln>
+                <a:solidFill>
+                  <a:srgbClr val="33D6B4"/>
+                </a:solidFill>
+              </a:ln>
+            </c:spPr>
+          </c:marker>
+          <c:cat>
+            <c:strRef>
+              <c:f>Sheet1!$A$2:$A$6</c:f>
+              <c:strCache>
+                <c:ptCount val="5"/>
+                <c:pt idx="0">
+                  <c:v>5</c:v>
+                </c:pt>
+                <c:pt idx="1">
+                  <c:v>10</c:v>
+                </c:pt>
+                <c:pt idx="2">
+                  <c:v>15</c:v>
+                </c:pt>
+                <c:pt idx="3">
+                  <c:v>20</c:v>
+                </c:pt>
+                <c:pt idx="4">
+                  <c:v>25 Baseline</c:v>
+                </c:pt>
+              </c:strCache>
+            </c:strRef>
+          </c:cat>
+          <c:val>
+            <c:numRef>
+              <c:f>Sheet1!$C$2:$C$6</c:f>
+              <c:numCache>
+                <c:formatCode>General</c:formatCode>
+                <c:ptCount val="5"/>
+                <c:pt idx="0">
+                  <c:v>1.915807046031348</c:v>
+                </c:pt>
+                <c:pt idx="1">
+                  <c:v>-0.6688262761231739</c:v>
+                </c:pt>
+                <c:pt idx="2">
+                  <c:v>-0.26964715262377253</c:v>
+                </c:pt>
+                <c:pt idx="3">
+                  <c:v>-0.7880114573822141</c:v>
+                </c:pt>
+              </c:numCache>
+            </c:numRef>
+          </c:val>
+          <c:smooth val="0"/>
+        </c:ser>
+        <c:ser>
+          <c:idx val="2"/>
+          <c:order val="2"/>
+          <c:tx>
+            <c:strRef>
+              <c:f>Sheet1!$D$1</c:f>
+              <c:strCache>
+                <c:ptCount val="1"/>
+                <c:pt idx="0">
+                  <c:v>Diversity</c:v>
+                </c:pt>
+              </c:strCache>
+            </c:strRef>
+          </c:tx>
+          <c:spPr>
+            <a:ln w="25400">
+              <a:solidFill>
+                <a:srgbClr val="B58CFF"/>
+              </a:solidFill>
+            </a:ln>
+          </c:spPr>
+          <c:marker>
+            <c:symbol val="circle"/>
+            <c:size val="6"/>
+            <c:spPr>
+              <a:solidFill>
+                <a:srgbClr val="B58CFF"/>
+              </a:solidFill>
+              <a:ln>
+                <a:solidFill>
+                  <a:srgbClr val="B58CFF"/>
+                </a:solidFill>
+              </a:ln>
+            </c:spPr>
+          </c:marker>
+          <c:cat>
+            <c:strRef>
+              <c:f>Sheet1!$A$2:$A$6</c:f>
+              <c:strCache>
+                <c:ptCount val="5"/>
+                <c:pt idx="0">
+                  <c:v>5</c:v>
+                </c:pt>
+                <c:pt idx="1">
+                  <c:v>10</c:v>
+                </c:pt>
+                <c:pt idx="2">
+                  <c:v>15</c:v>
+                </c:pt>
+                <c:pt idx="3">
+                  <c:v>20</c:v>
+                </c:pt>
+                <c:pt idx="4">
+                  <c:v>25 Baseline</c:v>
+                </c:pt>
+              </c:strCache>
+            </c:strRef>
+          </c:cat>
+          <c:val>
+            <c:numRef>
+              <c:f>Sheet1!$D$2:$D$6</c:f>
+              <c:numCache>
+                <c:formatCode>General</c:formatCode>
+                <c:ptCount val="5"/>
+                <c:pt idx="0">
+                  <c:v>1.011176697906907</c:v>
+                </c:pt>
+                <c:pt idx="1">
+                  <c:v>0.7136193938616063</c:v>
+                </c:pt>
+                <c:pt idx="2">
+                  <c:v>0.3061929014980801</c:v>
+                </c:pt>
+                <c:pt idx="3">
+                  <c:v>-0.5895962871131638</c:v>
+                </c:pt>
+              </c:numCache>
+            </c:numRef>
+          </c:val>
+          <c:smooth val="0"/>
+        </c:ser>
+        <c:ser>
+          <c:idx val="3"/>
+          <c:order val="3"/>
+          <c:tx>
+            <c:strRef>
+              <c:f>Sheet1!$E$1</c:f>
+              <c:strCache>
+                <c:ptCount val="1"/>
+                <c:pt idx="0">
+                  <c:v>ST Hard</c:v>
+                </c:pt>
+              </c:strCache>
+            </c:strRef>
+          </c:tx>
+          <c:spPr>
+            <a:ln w="25400">
+              <a:solidFill>
+                <a:srgbClr val="FF8A65"/>
+              </a:solidFill>
+            </a:ln>
+          </c:spPr>
+          <c:marker>
+            <c:symbol val="circle"/>
+            <c:size val="6"/>
+            <c:spPr>
+              <a:solidFill>
+                <a:srgbClr val="FF8A65"/>
+              </a:solidFill>
+              <a:ln>
+                <a:solidFill>
+                  <a:srgbClr val="FF8A65"/>
+                </a:solidFill>
+              </a:ln>
+            </c:spPr>
+          </c:marker>
+          <c:cat>
+            <c:strRef>
+              <c:f>Sheet1!$A$2:$A$6</c:f>
+              <c:strCache>
+                <c:ptCount val="5"/>
+                <c:pt idx="0">
+                  <c:v>5</c:v>
+                </c:pt>
+                <c:pt idx="1">
+                  <c:v>10</c:v>
+                </c:pt>
+                <c:pt idx="2">
+                  <c:v>15</c:v>
+                </c:pt>
+                <c:pt idx="3">
+                  <c:v>20</c:v>
+                </c:pt>
+                <c:pt idx="4">
+                  <c:v>25 Baseline</c:v>
+                </c:pt>
+              </c:strCache>
+            </c:strRef>
+          </c:cat>
+          <c:val>
+            <c:numRef>
+              <c:f>Sheet1!$E$2:$E$6</c:f>
+              <c:numCache>
+                <c:formatCode>General</c:formatCode>
+                <c:ptCount val="5"/>
+                <c:pt idx="0">
+                  <c:v>1.4281580931119584</c:v>
+                </c:pt>
+                <c:pt idx="1">
+                  <c:v>0.6432440030466936</c:v>
+                </c:pt>
+                <c:pt idx="2">
+                  <c:v>0.5503404040527013</c:v>
+                </c:pt>
+                <c:pt idx="3">
+                  <c:v>-0.8517959213112467</c:v>
+                </c:pt>
+              </c:numCache>
+            </c:numRef>
+          </c:val>
+          <c:smooth val="0"/>
+        </c:ser>
+        <c:ser>
+          <c:idx val="4"/>
+          <c:order val="4"/>
+          <c:tx>
+            <c:strRef>
+              <c:f>Sheet1!$F$1</c:f>
+              <c:strCache>
+                <c:ptCount val="1"/>
+                <c:pt idx="0">
+                  <c:v>Baseline-25</c:v>
+                </c:pt>
+              </c:strCache>
+            </c:strRef>
+          </c:tx>
+          <c:spPr>
+            <a:ln>
+              <a:solidFill>
+                <a:srgbClr val="F5C451"/>
+              </a:solidFill>
+            </a:ln>
+          </c:spPr>
+          <c:marker>
+            <c:symbol val="star"/>
+            <c:size val="11"/>
+            <c:spPr>
+              <a:solidFill>
+                <a:srgbClr val="F5C451"/>
+              </a:solidFill>
+              <a:ln>
+                <a:solidFill>
+                  <a:srgbClr val="B98918"/>
+                </a:solidFill>
+              </a:ln>
+            </c:spPr>
+          </c:marker>
+          <c:cat>
+            <c:strRef>
+              <c:f>Sheet1!$A$2:$A$6</c:f>
+              <c:strCache>
+                <c:ptCount val="5"/>
+                <c:pt idx="0">
+                  <c:v>5</c:v>
+                </c:pt>
+                <c:pt idx="1">
+                  <c:v>10</c:v>
+                </c:pt>
+                <c:pt idx="2">
+                  <c:v>15</c:v>
+                </c:pt>
+                <c:pt idx="3">
+                  <c:v>20</c:v>
+                </c:pt>
+                <c:pt idx="4">
+                  <c:v>25 Baseline</c:v>
+                </c:pt>
+              </c:strCache>
+            </c:strRef>
+          </c:cat>
+          <c:val>
+            <c:numRef>
+              <c:f>Sheet1!$F$2:$F$6</c:f>
+              <c:numCache>
+                <c:formatCode>General</c:formatCode>
+                <c:ptCount val="5"/>
+                <c:pt idx="4">
+                  <c:v>0.0</c:v>
+                </c:pt>
+              </c:numCache>
+            </c:numRef>
+          </c:val>
+          <c:smooth val="0"/>
+        </c:ser>
+        <c:marker val="1"/>
+        <c:smooth val="0"/>
+        <c:axId val="2118791784"/>
+        <c:axId val="2140495176"/>
+      </c:lineChart>
+      <c:catAx>
+        <c:axId val="2118791784"/>
+        <c:scaling>
+          <c:orientation val="minMax"/>
+        </c:scaling>
+        <c:delete val="0"/>
+        <c:axPos val="b"/>
+        <c:majorTickMark val="out"/>
+        <c:minorTickMark val="none"/>
+        <c:tickLblPos val="nextTo"/>
+        <c:txPr>
+          <a:bodyPr/>
+          <a:lstStyle/>
+          <a:p>
+            <a:pPr>
+              <a:defRPr sz="800">
+                <a:latin typeface="Arial"/>
+              </a:defRPr>
+            </a:pPr>
+          </a:p>
+        </c:txPr>
+        <c:crossAx val="2140495176"/>
+        <c:crosses val="autoZero"/>
+        <c:auto val="1"/>
+        <c:lblAlgn val="ctr"/>
+        <c:lblOffset val="100"/>
+        <c:noMultiLvlLbl val="0"/>
+      </c:catAx>
+      <c:valAx>
+        <c:axId val="2140495176"/>
+        <c:scaling>
+          <c:max val="9.0"/>
+          <c:min val="-9.0"/>
+        </c:scaling>
+        <c:delete val="0"/>
+        <c:axPos val="l"/>
+        <c:majorGridlines>
+          <c:spPr>
+            <a:ln>
+              <a:solidFill>
+                <a:srgbClr val="D8E0E8"/>
+              </a:solidFill>
+            </a:ln>
+          </c:spPr>
+        </c:majorGridlines>
+        <c:numFmt formatCode="0.0&quot;%&quot;" sourceLinked="0"/>
+        <c:majorTickMark val="out"/>
+        <c:minorTickMark val="none"/>
+        <c:tickLblPos val="nextTo"/>
+        <c:txPr>
+          <a:bodyPr/>
+          <a:lstStyle/>
+          <a:p>
+            <a:pPr>
+              <a:defRPr sz="800">
+                <a:latin typeface="Arial"/>
+              </a:defRPr>
+            </a:pPr>
+          </a:p>
+        </c:txPr>
+        <c:crossAx val="2118791784"/>
+        <c:crosses val="autoZero"/>
+        <c:majorUnit val="4.5"/>
+      </c:valAx>
+    </c:plotArea>
+    <c:plotVisOnly val="1"/>
+    <c:dispBlanksAs val="gap"/>
+    <c:showDLblsOverMax val="0"/>
+  </c:chart>
+  <c:txPr>
+    <a:bodyPr/>
+    <a:lstStyle/>
+    <a:p>
+      <a:pPr>
+        <a:defRPr sz="1800"/>
+      </a:pPr>
+      <a:endParaRPr lang="en-US"/>
+    </a:p>
+  </c:txPr>
+  <c:externalData r:id="rId1">
+    <c:autoUpdate val="0"/>
+  </c:externalData>
+</c:chartSpace>
+</file>
+
+<file path=ppt/charts/chart4.xml><?xml version="1.0" encoding="utf-8"?>
+<c:chartSpace xmlns:c="http://schemas.openxmlformats.org/drawingml/2006/chart" xmlns:a="http://schemas.openxmlformats.org/drawingml/2006/main" xmlns:r="http://schemas.openxmlformats.org/officeDocument/2006/relationships">
+  <c:date1904 val="0"/>
+  <c:style val="10"/>
+  <c:chart>
+    <c:autoTitleDeleted val="1"/>
+    <c:plotArea>
+      <c:lineChart>
+        <c:grouping val="standard"/>
+        <c:varyColors val="0"/>
+        <c:ser>
+          <c:idx val="0"/>
+          <c:order val="0"/>
+          <c:tx>
+            <c:strRef>
+              <c:f>Sheet1!$B$1</c:f>
+              <c:strCache>
+                <c:ptCount val="1"/>
+                <c:pt idx="0">
+                  <c:v>Random</c:v>
+                </c:pt>
+              </c:strCache>
+            </c:strRef>
+          </c:tx>
+          <c:spPr>
+            <a:ln w="25400">
+              <a:solidFill>
+                <a:srgbClr val="49A6FF"/>
+              </a:solidFill>
+            </a:ln>
+          </c:spPr>
+          <c:marker>
+            <c:symbol val="circle"/>
+            <c:size val="6"/>
+            <c:spPr>
+              <a:solidFill>
+                <a:srgbClr val="49A6FF"/>
+              </a:solidFill>
+              <a:ln>
+                <a:solidFill>
+                  <a:srgbClr val="49A6FF"/>
+                </a:solidFill>
+              </a:ln>
+            </c:spPr>
+          </c:marker>
+          <c:cat>
+            <c:strRef>
+              <c:f>Sheet1!$A$2:$A$6</c:f>
+              <c:strCache>
+                <c:ptCount val="5"/>
+                <c:pt idx="0">
+                  <c:v>5</c:v>
+                </c:pt>
+                <c:pt idx="1">
+                  <c:v>10</c:v>
+                </c:pt>
+                <c:pt idx="2">
+                  <c:v>15</c:v>
+                </c:pt>
+                <c:pt idx="3">
+                  <c:v>20</c:v>
+                </c:pt>
+                <c:pt idx="4">
+                  <c:v>25 Baseline</c:v>
+                </c:pt>
+              </c:strCache>
+            </c:strRef>
+          </c:cat>
+          <c:val>
+            <c:numRef>
+              <c:f>Sheet1!$B$2:$B$6</c:f>
+              <c:numCache>
+                <c:formatCode>General</c:formatCode>
+                <c:ptCount val="5"/>
+                <c:pt idx="0">
+                  <c:v>1.486306735922495</c:v>
+                </c:pt>
+                <c:pt idx="1">
+                  <c:v>0.8227024985598291</c:v>
+                </c:pt>
+                <c:pt idx="2">
+                  <c:v>-0.3805609563364909</c:v>
+                </c:pt>
+                <c:pt idx="3">
+                  <c:v>-0.0365443263731369</c:v>
+                </c:pt>
+              </c:numCache>
+            </c:numRef>
+          </c:val>
+          <c:smooth val="0"/>
+        </c:ser>
+        <c:ser>
+          <c:idx val="1"/>
+          <c:order val="1"/>
+          <c:tx>
+            <c:strRef>
+              <c:f>Sheet1!$C$1</c:f>
+              <c:strCache>
+                <c:ptCount val="1"/>
+                <c:pt idx="0">
+                  <c:v>Similarity</c:v>
+                </c:pt>
+              </c:strCache>
+            </c:strRef>
+          </c:tx>
+          <c:spPr>
+            <a:ln w="25400">
+              <a:solidFill>
+                <a:srgbClr val="33D6B4"/>
+              </a:solidFill>
+            </a:ln>
+          </c:spPr>
+          <c:marker>
+            <c:symbol val="circle"/>
+            <c:size val="6"/>
+            <c:spPr>
+              <a:solidFill>
+                <a:srgbClr val="33D6B4"/>
+              </a:solidFill>
+              <a:ln>
+                <a:solidFill>
+                  <a:srgbClr val="33D6B4"/>
+                </a:solidFill>
+              </a:ln>
+            </c:spPr>
+          </c:marker>
+          <c:cat>
+            <c:strRef>
+              <c:f>Sheet1!$A$2:$A$6</c:f>
+              <c:strCache>
+                <c:ptCount val="5"/>
+                <c:pt idx="0">
+                  <c:v>5</c:v>
+                </c:pt>
+                <c:pt idx="1">
+                  <c:v>10</c:v>
+                </c:pt>
+                <c:pt idx="2">
+                  <c:v>15</c:v>
+                </c:pt>
+                <c:pt idx="3">
+                  <c:v>20</c:v>
+                </c:pt>
+                <c:pt idx="4">
+                  <c:v>25 Baseline</c:v>
+                </c:pt>
+              </c:strCache>
+            </c:strRef>
+          </c:cat>
+          <c:val>
+            <c:numRef>
+              <c:f>Sheet1!$C$2:$C$6</c:f>
+              <c:numCache>
+                <c:formatCode>General</c:formatCode>
+                <c:ptCount val="5"/>
+                <c:pt idx="0">
+                  <c:v>0.9774072859559797</c:v>
+                </c:pt>
+                <c:pt idx="1">
+                  <c:v>0.9329481655889591</c:v>
+                </c:pt>
+                <c:pt idx="2">
+                  <c:v>1.6419174728791188</c:v>
+                </c:pt>
+                <c:pt idx="3">
+                  <c:v>1.0394637406552691</c:v>
+                </c:pt>
+              </c:numCache>
+            </c:numRef>
+          </c:val>
+          <c:smooth val="0"/>
+        </c:ser>
+        <c:ser>
+          <c:idx val="2"/>
+          <c:order val="2"/>
+          <c:tx>
+            <c:strRef>
+              <c:f>Sheet1!$D$1</c:f>
+              <c:strCache>
+                <c:ptCount val="1"/>
+                <c:pt idx="0">
+                  <c:v>Diversity</c:v>
+                </c:pt>
+              </c:strCache>
+            </c:strRef>
+          </c:tx>
+          <c:spPr>
+            <a:ln w="25400">
+              <a:solidFill>
+                <a:srgbClr val="B58CFF"/>
+              </a:solidFill>
+            </a:ln>
+          </c:spPr>
+          <c:marker>
+            <c:symbol val="circle"/>
+            <c:size val="6"/>
+            <c:spPr>
+              <a:solidFill>
+                <a:srgbClr val="B58CFF"/>
+              </a:solidFill>
+              <a:ln>
+                <a:solidFill>
+                  <a:srgbClr val="B58CFF"/>
+                </a:solidFill>
+              </a:ln>
+            </c:spPr>
+          </c:marker>
+          <c:cat>
+            <c:strRef>
+              <c:f>Sheet1!$A$2:$A$6</c:f>
+              <c:strCache>
+                <c:ptCount val="5"/>
+                <c:pt idx="0">
+                  <c:v>5</c:v>
+                </c:pt>
+                <c:pt idx="1">
+                  <c:v>10</c:v>
+                </c:pt>
+                <c:pt idx="2">
+                  <c:v>15</c:v>
+                </c:pt>
+                <c:pt idx="3">
+                  <c:v>20</c:v>
+                </c:pt>
+                <c:pt idx="4">
+                  <c:v>25 Baseline</c:v>
+                </c:pt>
+              </c:strCache>
+            </c:strRef>
+          </c:cat>
+          <c:val>
+            <c:numRef>
+              <c:f>Sheet1!$D$2:$D$6</c:f>
+              <c:numCache>
+                <c:formatCode>General</c:formatCode>
+                <c:ptCount val="5"/>
+                <c:pt idx="0">
+                  <c:v>0.05660931032044112</c:v>
+                </c:pt>
+                <c:pt idx="1">
+                  <c:v>-0.6444800891201443</c:v>
+                </c:pt>
+                <c:pt idx="2">
+                  <c:v>0.5305441221365657</c:v>
+                </c:pt>
+                <c:pt idx="3">
+                  <c:v>-0.539339791274656</c:v>
+                </c:pt>
+              </c:numCache>
+            </c:numRef>
+          </c:val>
+          <c:smooth val="0"/>
+        </c:ser>
+        <c:ser>
+          <c:idx val="3"/>
+          <c:order val="3"/>
+          <c:tx>
+            <c:strRef>
+              <c:f>Sheet1!$E$1</c:f>
+              <c:strCache>
+                <c:ptCount val="1"/>
+                <c:pt idx="0">
+                  <c:v>ST Hard</c:v>
+                </c:pt>
+              </c:strCache>
+            </c:strRef>
+          </c:tx>
+          <c:spPr>
+            <a:ln w="25400">
+              <a:solidFill>
+                <a:srgbClr val="FF8A65"/>
+              </a:solidFill>
+            </a:ln>
+          </c:spPr>
+          <c:marker>
+            <c:symbol val="circle"/>
+            <c:size val="6"/>
+            <c:spPr>
+              <a:solidFill>
+                <a:srgbClr val="FF8A65"/>
+              </a:solidFill>
+              <a:ln>
+                <a:solidFill>
+                  <a:srgbClr val="FF8A65"/>
+                </a:solidFill>
+              </a:ln>
+            </c:spPr>
+          </c:marker>
+          <c:cat>
+            <c:strRef>
+              <c:f>Sheet1!$A$2:$A$6</c:f>
+              <c:strCache>
+                <c:ptCount val="5"/>
+                <c:pt idx="0">
+                  <c:v>5</c:v>
+                </c:pt>
+                <c:pt idx="1">
+                  <c:v>10</c:v>
+                </c:pt>
+                <c:pt idx="2">
+                  <c:v>15</c:v>
+                </c:pt>
+                <c:pt idx="3">
+                  <c:v>20</c:v>
+                </c:pt>
+                <c:pt idx="4">
+                  <c:v>25 Baseline</c:v>
+                </c:pt>
+              </c:strCache>
+            </c:strRef>
+          </c:cat>
+          <c:val>
+            <c:numRef>
+              <c:f>Sheet1!$E$2:$E$6</c:f>
+              <c:numCache>
+                <c:formatCode>General</c:formatCode>
+                <c:ptCount val="5"/>
+                <c:pt idx="0">
+                  <c:v>-2.293153481886313</c:v>
+                </c:pt>
+                <c:pt idx="1">
+                  <c:v>-4.367080252446169</c:v>
+                </c:pt>
+                <c:pt idx="2">
+                  <c:v>-3.200632581733521</c:v>
+                </c:pt>
+                <c:pt idx="3">
+                  <c:v>-3.564137484070796</c:v>
+                </c:pt>
+              </c:numCache>
+            </c:numRef>
+          </c:val>
+          <c:smooth val="0"/>
+        </c:ser>
+        <c:ser>
+          <c:idx val="4"/>
+          <c:order val="4"/>
+          <c:tx>
+            <c:strRef>
+              <c:f>Sheet1!$F$1</c:f>
+              <c:strCache>
+                <c:ptCount val="1"/>
+                <c:pt idx="0">
+                  <c:v>Baseline-25</c:v>
+                </c:pt>
+              </c:strCache>
+            </c:strRef>
+          </c:tx>
+          <c:spPr>
+            <a:ln>
+              <a:solidFill>
+                <a:srgbClr val="F5C451"/>
+              </a:solidFill>
+            </a:ln>
+          </c:spPr>
+          <c:marker>
+            <c:symbol val="star"/>
+            <c:size val="11"/>
+            <c:spPr>
+              <a:solidFill>
+                <a:srgbClr val="F5C451"/>
+              </a:solidFill>
+              <a:ln>
+                <a:solidFill>
+                  <a:srgbClr val="B98918"/>
+                </a:solidFill>
+              </a:ln>
+            </c:spPr>
+          </c:marker>
+          <c:cat>
+            <c:strRef>
+              <c:f>Sheet1!$A$2:$A$6</c:f>
+              <c:strCache>
+                <c:ptCount val="5"/>
+                <c:pt idx="0">
+                  <c:v>5</c:v>
+                </c:pt>
+                <c:pt idx="1">
+                  <c:v>10</c:v>
+                </c:pt>
+                <c:pt idx="2">
+                  <c:v>15</c:v>
+                </c:pt>
+                <c:pt idx="3">
+                  <c:v>20</c:v>
+                </c:pt>
+                <c:pt idx="4">
+                  <c:v>25 Baseline</c:v>
+                </c:pt>
+              </c:strCache>
+            </c:strRef>
+          </c:cat>
+          <c:val>
+            <c:numRef>
+              <c:f>Sheet1!$F$2:$F$6</c:f>
+              <c:numCache>
+                <c:formatCode>General</c:formatCode>
+                <c:ptCount val="5"/>
+                <c:pt idx="4">
+                  <c:v>0.0</c:v>
+                </c:pt>
+              </c:numCache>
+            </c:numRef>
+          </c:val>
+          <c:smooth val="0"/>
+        </c:ser>
+        <c:marker val="1"/>
+        <c:smooth val="0"/>
+        <c:axId val="2118791784"/>
+        <c:axId val="2140495176"/>
+      </c:lineChart>
+      <c:catAx>
+        <c:axId val="2118791784"/>
+        <c:scaling>
+          <c:orientation val="minMax"/>
+        </c:scaling>
+        <c:delete val="0"/>
+        <c:axPos val="b"/>
+        <c:majorTickMark val="out"/>
+        <c:minorTickMark val="none"/>
+        <c:tickLblPos val="nextTo"/>
+        <c:txPr>
+          <a:bodyPr/>
+          <a:lstStyle/>
+          <a:p>
+            <a:pPr>
+              <a:defRPr sz="800">
+                <a:latin typeface="Arial"/>
+              </a:defRPr>
+            </a:pPr>
+          </a:p>
+        </c:txPr>
+        <c:crossAx val="2140495176"/>
+        <c:crosses val="autoZero"/>
+        <c:auto val="1"/>
+        <c:lblAlgn val="ctr"/>
+        <c:lblOffset val="100"/>
+        <c:noMultiLvlLbl val="0"/>
+      </c:catAx>
+      <c:valAx>
+        <c:axId val="2140495176"/>
+        <c:scaling>
+          <c:max val="9.0"/>
+          <c:min val="-9.0"/>
+        </c:scaling>
+        <c:delete val="0"/>
+        <c:axPos val="l"/>
+        <c:majorGridlines>
+          <c:spPr>
+            <a:ln>
+              <a:solidFill>
+                <a:srgbClr val="D8E0E8"/>
+              </a:solidFill>
+            </a:ln>
+          </c:spPr>
+        </c:majorGridlines>
+        <c:numFmt formatCode="0.0&quot;%&quot;" sourceLinked="0"/>
+        <c:majorTickMark val="out"/>
+        <c:minorTickMark val="none"/>
+        <c:tickLblPos val="nextTo"/>
+        <c:txPr>
+          <a:bodyPr/>
+          <a:lstStyle/>
+          <a:p>
+            <a:pPr>
+              <a:defRPr sz="800">
+                <a:latin typeface="Arial"/>
+              </a:defRPr>
+            </a:pPr>
+          </a:p>
+        </c:txPr>
+        <c:crossAx val="2118791784"/>
+        <c:crosses val="autoZero"/>
+        <c:majorUnit val="4.5"/>
+      </c:valAx>
+    </c:plotArea>
+    <c:plotVisOnly val="1"/>
+    <c:dispBlanksAs val="gap"/>
+    <c:showDLblsOverMax val="0"/>
+  </c:chart>
+  <c:txPr>
+    <a:bodyPr/>
+    <a:lstStyle/>
+    <a:p>
+      <a:pPr>
+        <a:defRPr sz="1800"/>
+      </a:pPr>
+      <a:endParaRPr lang="en-US"/>
+    </a:p>
+  </c:txPr>
+  <c:externalData r:id="rId1">
+    <c:autoUpdate val="0"/>
+  </c:externalData>
+</c:chartSpace>
+</file>
+
+<file path=ppt/charts/chart5.xml><?xml version="1.0" encoding="utf-8"?>
+<c:chartSpace xmlns:c="http://schemas.openxmlformats.org/drawingml/2006/chart" xmlns:a="http://schemas.openxmlformats.org/drawingml/2006/main" xmlns:r="http://schemas.openxmlformats.org/officeDocument/2006/relationships">
+  <c:date1904 val="0"/>
+  <c:style val="10"/>
+  <c:chart>
+    <c:autoTitleDeleted val="1"/>
+    <c:plotArea>
+      <c:lineChart>
+        <c:grouping val="standard"/>
+        <c:varyColors val="0"/>
+        <c:ser>
+          <c:idx val="0"/>
+          <c:order val="0"/>
+          <c:tx>
+            <c:strRef>
+              <c:f>Sheet1!$B$1</c:f>
+              <c:strCache>
+                <c:ptCount val="1"/>
+                <c:pt idx="0">
+                  <c:v>Random</c:v>
+                </c:pt>
+              </c:strCache>
+            </c:strRef>
+          </c:tx>
+          <c:spPr>
+            <a:ln w="25400">
+              <a:solidFill>
+                <a:srgbClr val="49A6FF"/>
+              </a:solidFill>
+            </a:ln>
+          </c:spPr>
+          <c:marker>
+            <c:symbol val="circle"/>
+            <c:size val="6"/>
+            <c:spPr>
+              <a:solidFill>
+                <a:srgbClr val="49A6FF"/>
+              </a:solidFill>
+              <a:ln>
+                <a:solidFill>
+                  <a:srgbClr val="49A6FF"/>
+                </a:solidFill>
+              </a:ln>
+            </c:spPr>
+          </c:marker>
+          <c:cat>
+            <c:strRef>
+              <c:f>Sheet1!$A$2:$A$6</c:f>
+              <c:strCache>
+                <c:ptCount val="5"/>
+                <c:pt idx="0">
+                  <c:v>5</c:v>
+                </c:pt>
+                <c:pt idx="1">
+                  <c:v>10</c:v>
+                </c:pt>
+                <c:pt idx="2">
+                  <c:v>15</c:v>
+                </c:pt>
+                <c:pt idx="3">
+                  <c:v>20</c:v>
+                </c:pt>
+                <c:pt idx="4">
+                  <c:v>25 Baseline</c:v>
+                </c:pt>
+              </c:strCache>
+            </c:strRef>
+          </c:cat>
+          <c:val>
+            <c:numRef>
+              <c:f>Sheet1!$B$2:$B$6</c:f>
+              <c:numCache>
+                <c:formatCode>General</c:formatCode>
+                <c:ptCount val="5"/>
+                <c:pt idx="0">
+                  <c:v>0.70203647202091</c:v>
+                </c:pt>
+                <c:pt idx="1">
+                  <c:v>0.2160181097851629</c:v>
+                </c:pt>
+                <c:pt idx="2">
+                  <c:v>-0.07934409939041681</c:v>
+                </c:pt>
+                <c:pt idx="3">
+                  <c:v>-0.01216488480356505</c:v>
+                </c:pt>
+              </c:numCache>
+            </c:numRef>
+          </c:val>
+          <c:smooth val="0"/>
+        </c:ser>
+        <c:ser>
+          <c:idx val="1"/>
+          <c:order val="1"/>
+          <c:tx>
+            <c:strRef>
+              <c:f>Sheet1!$C$1</c:f>
+              <c:strCache>
+                <c:ptCount val="1"/>
+                <c:pt idx="0">
+                  <c:v>Similarity</c:v>
+                </c:pt>
+              </c:strCache>
+            </c:strRef>
+          </c:tx>
+          <c:spPr>
+            <a:ln w="25400">
+              <a:solidFill>
+                <a:srgbClr val="33D6B4"/>
+              </a:solidFill>
+            </a:ln>
+          </c:spPr>
+          <c:marker>
+            <c:symbol val="circle"/>
+            <c:size val="6"/>
+            <c:spPr>
+              <a:solidFill>
+                <a:srgbClr val="33D6B4"/>
+              </a:solidFill>
+              <a:ln>
+                <a:solidFill>
+                  <a:srgbClr val="33D6B4"/>
+                </a:solidFill>
+              </a:ln>
+            </c:spPr>
+          </c:marker>
+          <c:cat>
+            <c:strRef>
+              <c:f>Sheet1!$A$2:$A$6</c:f>
+              <c:strCache>
+                <c:ptCount val="5"/>
+                <c:pt idx="0">
+                  <c:v>5</c:v>
+                </c:pt>
+                <c:pt idx="1">
+                  <c:v>10</c:v>
+                </c:pt>
+                <c:pt idx="2">
+                  <c:v>15</c:v>
+                </c:pt>
+                <c:pt idx="3">
+                  <c:v>20</c:v>
+                </c:pt>
+                <c:pt idx="4">
+                  <c:v>25 Baseline</c:v>
+                </c:pt>
+              </c:strCache>
+            </c:strRef>
+          </c:cat>
+          <c:val>
+            <c:numRef>
+              <c:f>Sheet1!$C$2:$C$6</c:f>
+              <c:numCache>
+                <c:formatCode>General</c:formatCode>
+                <c:ptCount val="5"/>
+                <c:pt idx="0">
+                  <c:v>0.2580044971024767</c:v>
+                </c:pt>
+                <c:pt idx="1">
+                  <c:v>0.47663996811743947</c:v>
+                </c:pt>
+                <c:pt idx="2">
+                  <c:v>0.9128439022592586</c:v>
+                </c:pt>
+                <c:pt idx="3">
+                  <c:v>0.28543994778874227</c:v>
+                </c:pt>
+              </c:numCache>
+            </c:numRef>
+          </c:val>
+          <c:smooth val="0"/>
+        </c:ser>
+        <c:ser>
+          <c:idx val="2"/>
+          <c:order val="2"/>
+          <c:tx>
+            <c:strRef>
+              <c:f>Sheet1!$D$1</c:f>
+              <c:strCache>
+                <c:ptCount val="1"/>
+                <c:pt idx="0">
+                  <c:v>Diversity</c:v>
+                </c:pt>
+              </c:strCache>
+            </c:strRef>
+          </c:tx>
+          <c:spPr>
+            <a:ln w="25400">
+              <a:solidFill>
+                <a:srgbClr val="B58CFF"/>
+              </a:solidFill>
+            </a:ln>
+          </c:spPr>
+          <c:marker>
+            <c:symbol val="circle"/>
+            <c:size val="6"/>
+            <c:spPr>
+              <a:solidFill>
+                <a:srgbClr val="B58CFF"/>
+              </a:solidFill>
+              <a:ln>
+                <a:solidFill>
+                  <a:srgbClr val="B58CFF"/>
+                </a:solidFill>
+              </a:ln>
+            </c:spPr>
+          </c:marker>
+          <c:cat>
+            <c:strRef>
+              <c:f>Sheet1!$A$2:$A$6</c:f>
+              <c:strCache>
+                <c:ptCount val="5"/>
+                <c:pt idx="0">
+                  <c:v>5</c:v>
+                </c:pt>
+                <c:pt idx="1">
+                  <c:v>10</c:v>
+                </c:pt>
+                <c:pt idx="2">
+                  <c:v>15</c:v>
+                </c:pt>
+                <c:pt idx="3">
+                  <c:v>20</c:v>
+                </c:pt>
+                <c:pt idx="4">
+                  <c:v>25 Baseline</c:v>
+                </c:pt>
+              </c:strCache>
+            </c:strRef>
+          </c:cat>
+          <c:val>
+            <c:numRef>
+              <c:f>Sheet1!$D$2:$D$6</c:f>
+              <c:numCache>
+                <c:formatCode>General</c:formatCode>
+                <c:ptCount val="5"/>
+                <c:pt idx="0">
+                  <c:v>-0.12049976261768955</c:v>
+                </c:pt>
+                <c:pt idx="1">
+                  <c:v>-0.6176317540220871</c:v>
+                </c:pt>
+                <c:pt idx="2">
+                  <c:v>-0.14068005710440507</c:v>
+                </c:pt>
+                <c:pt idx="3">
+                  <c:v>-0.5011123370693671</c:v>
+                </c:pt>
+              </c:numCache>
+            </c:numRef>
+          </c:val>
+          <c:smooth val="0"/>
+        </c:ser>
+        <c:ser>
+          <c:idx val="3"/>
+          <c:order val="3"/>
+          <c:tx>
+            <c:strRef>
+              <c:f>Sheet1!$E$1</c:f>
+              <c:strCache>
+                <c:ptCount val="1"/>
+                <c:pt idx="0">
+                  <c:v>ST Hard</c:v>
+                </c:pt>
+              </c:strCache>
+            </c:strRef>
+          </c:tx>
+          <c:spPr>
+            <a:ln w="25400">
+              <a:solidFill>
+                <a:srgbClr val="FF8A65"/>
+              </a:solidFill>
+            </a:ln>
+          </c:spPr>
+          <c:marker>
+            <c:symbol val="circle"/>
+            <c:size val="6"/>
+            <c:spPr>
+              <a:solidFill>
+                <a:srgbClr val="FF8A65"/>
+              </a:solidFill>
+              <a:ln>
+                <a:solidFill>
+                  <a:srgbClr val="FF8A65"/>
+                </a:solidFill>
+              </a:ln>
+            </c:spPr>
+          </c:marker>
+          <c:cat>
+            <c:strRef>
+              <c:f>Sheet1!$A$2:$A$6</c:f>
+              <c:strCache>
+                <c:ptCount val="5"/>
+                <c:pt idx="0">
+                  <c:v>5</c:v>
+                </c:pt>
+                <c:pt idx="1">
+                  <c:v>10</c:v>
+                </c:pt>
+                <c:pt idx="2">
+                  <c:v>15</c:v>
+                </c:pt>
+                <c:pt idx="3">
+                  <c:v>20</c:v>
+                </c:pt>
+                <c:pt idx="4">
+                  <c:v>25 Baseline</c:v>
+                </c:pt>
+              </c:strCache>
+            </c:strRef>
+          </c:cat>
+          <c:val>
+            <c:numRef>
+              <c:f>Sheet1!$E$2:$E$6</c:f>
+              <c:numCache>
+                <c:formatCode>General</c:formatCode>
+                <c:ptCount val="5"/>
+                <c:pt idx="0">
+                  <c:v>-0.5705134484240056</c:v>
+                </c:pt>
+                <c:pt idx="1">
+                  <c:v>-1.6824094547013366</c:v>
+                </c:pt>
+                <c:pt idx="2">
+                  <c:v>-1.0156464229348041</c:v>
+                </c:pt>
+                <c:pt idx="3">
+                  <c:v>-1.243733245872402</c:v>
+                </c:pt>
+              </c:numCache>
+            </c:numRef>
+          </c:val>
+          <c:smooth val="0"/>
+        </c:ser>
+        <c:ser>
+          <c:idx val="4"/>
+          <c:order val="4"/>
+          <c:tx>
+            <c:strRef>
+              <c:f>Sheet1!$F$1</c:f>
+              <c:strCache>
+                <c:ptCount val="1"/>
+                <c:pt idx="0">
+                  <c:v>Baseline-25</c:v>
+                </c:pt>
+              </c:strCache>
+            </c:strRef>
+          </c:tx>
+          <c:spPr>
+            <a:ln>
+              <a:solidFill>
+                <a:srgbClr val="F5C451"/>
+              </a:solidFill>
+            </a:ln>
+          </c:spPr>
+          <c:marker>
+            <c:symbol val="star"/>
+            <c:size val="11"/>
+            <c:spPr>
+              <a:solidFill>
+                <a:srgbClr val="F5C451"/>
+              </a:solidFill>
+              <a:ln>
+                <a:solidFill>
+                  <a:srgbClr val="B98918"/>
+                </a:solidFill>
+              </a:ln>
+            </c:spPr>
+          </c:marker>
+          <c:cat>
+            <c:strRef>
+              <c:f>Sheet1!$A$2:$A$6</c:f>
+              <c:strCache>
+                <c:ptCount val="5"/>
+                <c:pt idx="0">
+                  <c:v>5</c:v>
+                </c:pt>
+                <c:pt idx="1">
+                  <c:v>10</c:v>
+                </c:pt>
+                <c:pt idx="2">
+                  <c:v>15</c:v>
+                </c:pt>
+                <c:pt idx="3">
+                  <c:v>20</c:v>
+                </c:pt>
+                <c:pt idx="4">
+                  <c:v>25 Baseline</c:v>
+                </c:pt>
+              </c:strCache>
+            </c:strRef>
+          </c:cat>
+          <c:val>
+            <c:numRef>
+              <c:f>Sheet1!$F$2:$F$6</c:f>
+              <c:numCache>
+                <c:formatCode>General</c:formatCode>
+                <c:ptCount val="5"/>
+                <c:pt idx="4">
+                  <c:v>0.0</c:v>
+                </c:pt>
+              </c:numCache>
+            </c:numRef>
+          </c:val>
+          <c:smooth val="0"/>
+        </c:ser>
+        <c:marker val="1"/>
+        <c:smooth val="0"/>
+        <c:axId val="2118791784"/>
+        <c:axId val="2140495176"/>
+      </c:lineChart>
+      <c:catAx>
+        <c:axId val="2118791784"/>
+        <c:scaling>
+          <c:orientation val="minMax"/>
+        </c:scaling>
+        <c:delete val="0"/>
+        <c:axPos val="b"/>
+        <c:majorTickMark val="out"/>
+        <c:minorTickMark val="none"/>
+        <c:tickLblPos val="nextTo"/>
+        <c:txPr>
+          <a:bodyPr/>
+          <a:lstStyle/>
+          <a:p>
+            <a:pPr>
+              <a:defRPr sz="800">
+                <a:latin typeface="Arial"/>
+              </a:defRPr>
+            </a:pPr>
+          </a:p>
+        </c:txPr>
+        <c:crossAx val="2140495176"/>
+        <c:crosses val="autoZero"/>
+        <c:auto val="1"/>
+        <c:lblAlgn val="ctr"/>
+        <c:lblOffset val="100"/>
+        <c:noMultiLvlLbl val="0"/>
+      </c:catAx>
+      <c:valAx>
+        <c:axId val="2140495176"/>
+        <c:scaling>
+          <c:max val="9.0"/>
+          <c:min val="-9.0"/>
+        </c:scaling>
+        <c:delete val="0"/>
+        <c:axPos val="l"/>
+        <c:majorGridlines>
+          <c:spPr>
+            <a:ln>
+              <a:solidFill>
+                <a:srgbClr val="D8E0E8"/>
+              </a:solidFill>
+            </a:ln>
+          </c:spPr>
+        </c:majorGridlines>
+        <c:numFmt formatCode="0.0&quot;%&quot;" sourceLinked="0"/>
+        <c:majorTickMark val="out"/>
+        <c:minorTickMark val="none"/>
+        <c:tickLblPos val="nextTo"/>
+        <c:txPr>
+          <a:bodyPr/>
+          <a:lstStyle/>
+          <a:p>
+            <a:pPr>
+              <a:defRPr sz="800">
+                <a:latin typeface="Arial"/>
+              </a:defRPr>
+            </a:pPr>
+          </a:p>
+        </c:txPr>
+        <c:crossAx val="2118791784"/>
+        <c:crosses val="autoZero"/>
+        <c:majorUnit val="4.5"/>
+      </c:valAx>
+    </c:plotArea>
+    <c:plotVisOnly val="1"/>
+    <c:dispBlanksAs val="gap"/>
+    <c:showDLblsOverMax val="0"/>
+  </c:chart>
+  <c:txPr>
+    <a:bodyPr/>
+    <a:lstStyle/>
+    <a:p>
+      <a:pPr>
+        <a:defRPr sz="1800"/>
+      </a:pPr>
+      <a:endParaRPr lang="en-US"/>
+    </a:p>
+  </c:txPr>
+  <c:externalData r:id="rId1">
+    <c:autoUpdate val="0"/>
+  </c:externalData>
+</c:chartSpace>
 </file>
 
 <file path=ppt/slideLayouts/slideLayout1.xml><?xml version="1.0" encoding="utf-8"?>
@@ -3081,6 +5561,14 @@
 <file path=ppt/slides/slide1.xml><?xml version="1.0" encoding="utf-8"?>
 <p:sld xmlns:a="http://schemas.openxmlformats.org/drawingml/2006/main" xmlns:p="http://schemas.openxmlformats.org/presentationml/2006/main" xmlns:r="http://schemas.openxmlformats.org/officeDocument/2006/relationships">
   <p:cSld>
+    <p:bg>
+      <p:bgPr>
+        <a:solidFill>
+          <a:srgbClr val="FFFFFF"/>
+        </a:solidFill>
+        <a:effectLst/>
+      </p:bgPr>
+    </p:bg>
     <p:spTree>
       <p:nvGrpSpPr>
         <p:cNvPr id="1" name=""/>
@@ -3088,30 +5576,792 @@
         <p:nvPr/>
       </p:nvGrpSpPr>
       <p:grpSpPr/>
-      <p:pic>
-        <p:nvPicPr>
-          <p:cNvPr id="2" name="Picture 1" descr="01_patch_budget_trends.png"/>
-          <p:cNvPicPr>
-            <a:picLocks noChangeAspect="1"/>
-          </p:cNvPicPr>
+      <p:sp>
+        <p:nvSpPr>
+          <p:cNvPr id="2" name="TextBox 1"/>
+          <p:cNvSpPr txBox="1"/>
           <p:nvPr/>
-        </p:nvPicPr>
-        <p:blipFill>
-          <a:blip r:embed="rId2"/>
-          <a:stretch>
-            <a:fillRect/>
-          </a:stretch>
-        </p:blipFill>
+        </p:nvSpPr>
         <p:spPr>
           <a:xfrm>
-            <a:off x="0" y="0"/>
-            <a:ext cx="12191695" cy="6858000"/>
+            <a:off x="347472" y="146304"/>
+            <a:ext cx="11338560" cy="411480"/>
           </a:xfrm>
           <a:prstGeom prst="rect">
             <a:avLst/>
           </a:prstGeom>
+          <a:noFill/>
         </p:spPr>
-      </p:pic>
+        <p:txBody>
+          <a:bodyPr wrap="none">
+            <a:spAutoFit/>
+          </a:bodyPr>
+          <a:lstStyle/>
+          <a:p>
+            <a:pPr>
+              <a:defRPr sz="2200" b="1">
+                <a:solidFill>
+                  <a:srgbClr val="17212B"/>
+                </a:solidFill>
+                <a:latin typeface="Arial"/>
+              </a:defRPr>
+            </a:pPr>
+            <a:r>
+              <a:t>PATCH BUDGET — PERFORMANCE ACROSS K</a:t>
+            </a:r>
+          </a:p>
+        </p:txBody>
+      </p:sp>
+      <p:sp>
+        <p:nvSpPr>
+          <p:cNvPr id="3" name="TextBox 2"/>
+          <p:cNvSpPr txBox="1"/>
+          <p:nvPr/>
+        </p:nvSpPr>
+        <p:spPr>
+          <a:xfrm>
+            <a:off x="356616" y="530352"/>
+            <a:ext cx="10972800" cy="246888"/>
+          </a:xfrm>
+          <a:prstGeom prst="rect">
+            <a:avLst/>
+          </a:prstGeom>
+          <a:noFill/>
+        </p:spPr>
+        <p:txBody>
+          <a:bodyPr wrap="none">
+            <a:spAutoFit/>
+          </a:bodyPr>
+          <a:lstStyle/>
+          <a:p>
+            <a:pPr>
+              <a:defRPr sz="1050" b="0">
+                <a:solidFill>
+                  <a:srgbClr val="526273"/>
+                </a:solidFill>
+                <a:latin typeface="Arial"/>
+              </a:defRPr>
+            </a:pPr>
+            <a:r>
+              <a:t>Change relative to the original TRIPLEX model using 25 patches</a:t>
+            </a:r>
+          </a:p>
+        </p:txBody>
+      </p:sp>
+      <p:sp>
+        <p:nvSpPr>
+          <p:cNvPr id="4" name="TextBox 3"/>
+          <p:cNvSpPr txBox="1"/>
+          <p:nvPr/>
+        </p:nvSpPr>
+        <p:spPr>
+          <a:xfrm>
+            <a:off x="320040" y="813816"/>
+            <a:ext cx="3657600" cy="347472"/>
+          </a:xfrm>
+          <a:prstGeom prst="rect">
+            <a:avLst/>
+          </a:prstGeom>
+          <a:noFill/>
+        </p:spPr>
+        <p:txBody>
+          <a:bodyPr wrap="none">
+            <a:spAutoFit/>
+          </a:bodyPr>
+          <a:lstStyle/>
+          <a:p>
+            <a:pPr algn="ctr">
+              <a:defRPr sz="1050" b="1">
+                <a:solidFill>
+                  <a:srgbClr val="17212B"/>
+                </a:solidFill>
+                <a:latin typeface="Arial"/>
+              </a:defRPr>
+            </a:pPr>
+            <a:r>
+              <a:t>CCC ↑  ·  Agreement in trend, mean and variance</a:t>
+            </a:r>
+          </a:p>
+        </p:txBody>
+      </p:sp>
+      <p:graphicFrame>
+        <p:nvGraphicFramePr>
+          <p:cNvPr id="5" name="Chart 4"/>
+          <p:cNvGraphicFramePr>
+            <a:graphicFrameLocks noGrp="1"/>
+          </p:cNvGraphicFramePr>
+          <p:nvPr/>
+        </p:nvGraphicFramePr>
+        <p:xfrm>
+          <a:off x="320040" y="1170432"/>
+          <a:ext cx="3657600" cy="2231136"/>
+        </p:xfrm>
+        <a:graphic>
+          <a:graphicData uri="http://schemas.openxmlformats.org/drawingml/2006/chart">
+            <c:chart xmlns:c="http://schemas.openxmlformats.org/drawingml/2006/chart" r:id="rId2"/>
+          </a:graphicData>
+        </a:graphic>
+      </p:graphicFrame>
+      <p:sp>
+        <p:nvSpPr>
+          <p:cNvPr id="6" name="TextBox 5"/>
+          <p:cNvSpPr txBox="1"/>
+          <p:nvPr/>
+        </p:nvSpPr>
+        <p:spPr>
+          <a:xfrm>
+            <a:off x="4261104" y="813816"/>
+            <a:ext cx="3657600" cy="347472"/>
+          </a:xfrm>
+          <a:prstGeom prst="rect">
+            <a:avLst/>
+          </a:prstGeom>
+          <a:noFill/>
+        </p:spPr>
+        <p:txBody>
+          <a:bodyPr wrap="none">
+            <a:spAutoFit/>
+          </a:bodyPr>
+          <a:lstStyle/>
+          <a:p>
+            <a:pPr algn="ctr">
+              <a:defRPr sz="1050" b="1">
+                <a:solidFill>
+                  <a:srgbClr val="17212B"/>
+                </a:solidFill>
+                <a:latin typeface="Arial"/>
+              </a:defRPr>
+            </a:pPr>
+            <a:r>
+              <a:t>PCC(M) ↑  ·  Mean correlation across 250 genes</a:t>
+            </a:r>
+          </a:p>
+        </p:txBody>
+      </p:sp>
+      <p:graphicFrame>
+        <p:nvGraphicFramePr>
+          <p:cNvPr id="7" name="Chart 6"/>
+          <p:cNvGraphicFramePr>
+            <a:graphicFrameLocks noGrp="1"/>
+          </p:cNvGraphicFramePr>
+          <p:nvPr/>
+        </p:nvGraphicFramePr>
+        <p:xfrm>
+          <a:off x="4261104" y="1170432"/>
+          <a:ext cx="3657600" cy="2231136"/>
+        </p:xfrm>
+        <a:graphic>
+          <a:graphicData uri="http://schemas.openxmlformats.org/drawingml/2006/chart">
+            <c:chart xmlns:c="http://schemas.openxmlformats.org/drawingml/2006/chart" r:id="rId3"/>
+          </a:graphicData>
+        </a:graphic>
+      </p:graphicFrame>
+      <p:sp>
+        <p:nvSpPr>
+          <p:cNvPr id="8" name="TextBox 7"/>
+          <p:cNvSpPr txBox="1"/>
+          <p:nvPr/>
+        </p:nvSpPr>
+        <p:spPr>
+          <a:xfrm>
+            <a:off x="8202168" y="813816"/>
+            <a:ext cx="3657600" cy="347472"/>
+          </a:xfrm>
+          <a:prstGeom prst="rect">
+            <a:avLst/>
+          </a:prstGeom>
+          <a:noFill/>
+        </p:spPr>
+        <p:txBody>
+          <a:bodyPr wrap="none">
+            <a:spAutoFit/>
+          </a:bodyPr>
+          <a:lstStyle/>
+          <a:p>
+            <a:pPr algn="ctr">
+              <a:defRPr sz="1050" b="1">
+                <a:solidFill>
+                  <a:srgbClr val="17212B"/>
+                </a:solidFill>
+                <a:latin typeface="Arial"/>
+              </a:defRPr>
+            </a:pPr>
+            <a:r>
+              <a:t>PCC(H) ↑  ·  Mean correlation across top-50 genes</a:t>
+            </a:r>
+          </a:p>
+        </p:txBody>
+      </p:sp>
+      <p:graphicFrame>
+        <p:nvGraphicFramePr>
+          <p:cNvPr id="9" name="Chart 8"/>
+          <p:cNvGraphicFramePr>
+            <a:graphicFrameLocks noGrp="1"/>
+          </p:cNvGraphicFramePr>
+          <p:nvPr/>
+        </p:nvGraphicFramePr>
+        <p:xfrm>
+          <a:off x="8202168" y="1170432"/>
+          <a:ext cx="3657600" cy="2231136"/>
+        </p:xfrm>
+        <a:graphic>
+          <a:graphicData uri="http://schemas.openxmlformats.org/drawingml/2006/chart">
+            <c:chart xmlns:c="http://schemas.openxmlformats.org/drawingml/2006/chart" r:id="rId4"/>
+          </a:graphicData>
+        </a:graphic>
+      </p:graphicFrame>
+      <p:sp>
+        <p:nvSpPr>
+          <p:cNvPr id="10" name="TextBox 9"/>
+          <p:cNvSpPr txBox="1"/>
+          <p:nvPr/>
+        </p:nvSpPr>
+        <p:spPr>
+          <a:xfrm>
+            <a:off x="320040" y="3547872"/>
+            <a:ext cx="3657600" cy="347472"/>
+          </a:xfrm>
+          <a:prstGeom prst="rect">
+            <a:avLst/>
+          </a:prstGeom>
+          <a:noFill/>
+        </p:spPr>
+        <p:txBody>
+          <a:bodyPr wrap="none">
+            <a:spAutoFit/>
+          </a:bodyPr>
+          <a:lstStyle/>
+          <a:p>
+            <a:pPr algn="ctr">
+              <a:defRPr sz="1050" b="1">
+                <a:solidFill>
+                  <a:srgbClr val="17212B"/>
+                </a:solidFill>
+                <a:latin typeface="Arial"/>
+              </a:defRPr>
+            </a:pPr>
+            <a:r>
+              <a:t>MSE ↓  ·  Large errors count more</a:t>
+            </a:r>
+          </a:p>
+        </p:txBody>
+      </p:sp>
+      <p:graphicFrame>
+        <p:nvGraphicFramePr>
+          <p:cNvPr id="11" name="Chart 10"/>
+          <p:cNvGraphicFramePr>
+            <a:graphicFrameLocks noGrp="1"/>
+          </p:cNvGraphicFramePr>
+          <p:nvPr/>
+        </p:nvGraphicFramePr>
+        <p:xfrm>
+          <a:off x="320040" y="3904487"/>
+          <a:ext cx="3657600" cy="2231136"/>
+        </p:xfrm>
+        <a:graphic>
+          <a:graphicData uri="http://schemas.openxmlformats.org/drawingml/2006/chart">
+            <c:chart xmlns:c="http://schemas.openxmlformats.org/drawingml/2006/chart" r:id="rId5"/>
+          </a:graphicData>
+        </a:graphic>
+      </p:graphicFrame>
+      <p:sp>
+        <p:nvSpPr>
+          <p:cNvPr id="12" name="TextBox 11"/>
+          <p:cNvSpPr txBox="1"/>
+          <p:nvPr/>
+        </p:nvSpPr>
+        <p:spPr>
+          <a:xfrm>
+            <a:off x="4261104" y="3547872"/>
+            <a:ext cx="3657600" cy="347472"/>
+          </a:xfrm>
+          <a:prstGeom prst="rect">
+            <a:avLst/>
+          </a:prstGeom>
+          <a:noFill/>
+        </p:spPr>
+        <p:txBody>
+          <a:bodyPr wrap="none">
+            <a:spAutoFit/>
+          </a:bodyPr>
+          <a:lstStyle/>
+          <a:p>
+            <a:pPr algn="ctr">
+              <a:defRPr sz="1050" b="1">
+                <a:solidFill>
+                  <a:srgbClr val="17212B"/>
+                </a:solidFill>
+                <a:latin typeface="Arial"/>
+              </a:defRPr>
+            </a:pPr>
+            <a:r>
+              <a:t>MAE ↓  ·  Average absolute prediction error</a:t>
+            </a:r>
+          </a:p>
+        </p:txBody>
+      </p:sp>
+      <p:graphicFrame>
+        <p:nvGraphicFramePr>
+          <p:cNvPr id="13" name="Chart 12"/>
+          <p:cNvGraphicFramePr>
+            <a:graphicFrameLocks noGrp="1"/>
+          </p:cNvGraphicFramePr>
+          <p:nvPr/>
+        </p:nvGraphicFramePr>
+        <p:xfrm>
+          <a:off x="4261104" y="3904487"/>
+          <a:ext cx="3657600" cy="2231136"/>
+        </p:xfrm>
+        <a:graphic>
+          <a:graphicData uri="http://schemas.openxmlformats.org/drawingml/2006/chart">
+            <c:chart xmlns:c="http://schemas.openxmlformats.org/drawingml/2006/chart" r:id="rId6"/>
+          </a:graphicData>
+        </a:graphic>
+      </p:graphicFrame>
+      <p:sp>
+        <p:nvSpPr>
+          <p:cNvPr id="14" name="TextBox 13"/>
+          <p:cNvSpPr txBox="1"/>
+          <p:nvPr/>
+        </p:nvSpPr>
+        <p:spPr>
+          <a:xfrm>
+            <a:off x="8275320" y="3840480"/>
+            <a:ext cx="3383280" cy="320040"/>
+          </a:xfrm>
+          <a:prstGeom prst="rect">
+            <a:avLst/>
+          </a:prstGeom>
+          <a:noFill/>
+        </p:spPr>
+        <p:txBody>
+          <a:bodyPr wrap="none">
+            <a:spAutoFit/>
+          </a:bodyPr>
+          <a:lstStyle/>
+          <a:p>
+            <a:pPr>
+              <a:defRPr sz="1200" b="1">
+                <a:solidFill>
+                  <a:srgbClr val="248DB8"/>
+                </a:solidFill>
+                <a:latin typeface="Arial"/>
+              </a:defRPr>
+            </a:pPr>
+            <a:r>
+              <a:t>HOW TO READ</a:t>
+            </a:r>
+          </a:p>
+        </p:txBody>
+      </p:sp>
+      <p:sp>
+        <p:nvSpPr>
+          <p:cNvPr id="15" name="TextBox 14"/>
+          <p:cNvSpPr txBox="1"/>
+          <p:nvPr/>
+        </p:nvSpPr>
+        <p:spPr>
+          <a:xfrm>
+            <a:off x="8275320" y="4224528"/>
+            <a:ext cx="3429000" cy="822960"/>
+          </a:xfrm>
+          <a:prstGeom prst="rect">
+            <a:avLst/>
+          </a:prstGeom>
+          <a:noFill/>
+        </p:spPr>
+        <p:txBody>
+          <a:bodyPr wrap="none">
+            <a:spAutoFit/>
+          </a:bodyPr>
+          <a:lstStyle/>
+          <a:p>
+            <a:pPr>
+              <a:defRPr sz="1000" b="0">
+                <a:solidFill>
+                  <a:srgbClr val="17212B"/>
+                </a:solidFill>
+                <a:latin typeface="Arial"/>
+              </a:defRPr>
+            </a:pPr>
+            <a:r>
+              <a:t>0% = original TRIPLEX with 25 patches</a:t>
+            </a:r>
+            <a:br/>
+            <a:r>
+              <a:t>Above 0 = better than Baseline-25</a:t>
+            </a:r>
+            <a:br/>
+            <a:r>
+              <a:t>Below 0 = worse than Baseline-25</a:t>
+            </a:r>
+          </a:p>
+        </p:txBody>
+      </p:sp>
+      <p:sp>
+        <p:nvSpPr>
+          <p:cNvPr id="16" name="Oval 15"/>
+          <p:cNvSpPr/>
+          <p:nvPr/>
+        </p:nvSpPr>
+        <p:spPr>
+          <a:xfrm>
+            <a:off x="8275320" y="5266944"/>
+            <a:ext cx="109728" cy="109728"/>
+          </a:xfrm>
+          <a:prstGeom prst="ellipse">
+            <a:avLst/>
+          </a:prstGeom>
+          <a:solidFill>
+            <a:srgbClr val="49A6FF"/>
+          </a:solidFill>
+          <a:ln>
+            <a:solidFill>
+              <a:srgbClr val="49A6FF"/>
+            </a:solidFill>
+          </a:ln>
+        </p:spPr>
+        <p:style>
+          <a:lnRef idx="1">
+            <a:schemeClr val="accent1"/>
+          </a:lnRef>
+          <a:fillRef idx="3">
+            <a:schemeClr val="accent1"/>
+          </a:fillRef>
+          <a:effectRef idx="2">
+            <a:schemeClr val="accent1"/>
+          </a:effectRef>
+          <a:fontRef idx="minor">
+            <a:schemeClr val="lt1"/>
+          </a:fontRef>
+        </p:style>
+        <p:txBody>
+          <a:bodyPr rtlCol="0" anchor="ctr"/>
+          <a:lstStyle/>
+          <a:p>
+            <a:pPr algn="ctr"/>
+          </a:p>
+        </p:txBody>
+      </p:sp>
+      <p:sp>
+        <p:nvSpPr>
+          <p:cNvPr id="17" name="TextBox 16"/>
+          <p:cNvSpPr txBox="1"/>
+          <p:nvPr/>
+        </p:nvSpPr>
+        <p:spPr>
+          <a:xfrm>
+            <a:off x="8430768" y="5212080"/>
+            <a:ext cx="1417320" cy="228600"/>
+          </a:xfrm>
+          <a:prstGeom prst="rect">
+            <a:avLst/>
+          </a:prstGeom>
+          <a:noFill/>
+        </p:spPr>
+        <p:txBody>
+          <a:bodyPr wrap="none">
+            <a:spAutoFit/>
+          </a:bodyPr>
+          <a:lstStyle/>
+          <a:p>
+            <a:pPr>
+              <a:defRPr sz="950" b="0">
+                <a:solidFill>
+                  <a:srgbClr val="17212B"/>
+                </a:solidFill>
+                <a:latin typeface="Arial"/>
+              </a:defRPr>
+            </a:pPr>
+            <a:r>
+              <a:t>Random</a:t>
+            </a:r>
+          </a:p>
+        </p:txBody>
+      </p:sp>
+      <p:sp>
+        <p:nvSpPr>
+          <p:cNvPr id="18" name="Oval 17"/>
+          <p:cNvSpPr/>
+          <p:nvPr/>
+        </p:nvSpPr>
+        <p:spPr>
+          <a:xfrm>
+            <a:off x="9939528" y="5266944"/>
+            <a:ext cx="109728" cy="109728"/>
+          </a:xfrm>
+          <a:prstGeom prst="ellipse">
+            <a:avLst/>
+          </a:prstGeom>
+          <a:solidFill>
+            <a:srgbClr val="33D6B4"/>
+          </a:solidFill>
+          <a:ln>
+            <a:solidFill>
+              <a:srgbClr val="33D6B4"/>
+            </a:solidFill>
+          </a:ln>
+        </p:spPr>
+        <p:style>
+          <a:lnRef idx="1">
+            <a:schemeClr val="accent1"/>
+          </a:lnRef>
+          <a:fillRef idx="3">
+            <a:schemeClr val="accent1"/>
+          </a:fillRef>
+          <a:effectRef idx="2">
+            <a:schemeClr val="accent1"/>
+          </a:effectRef>
+          <a:fontRef idx="minor">
+            <a:schemeClr val="lt1"/>
+          </a:fontRef>
+        </p:style>
+        <p:txBody>
+          <a:bodyPr rtlCol="0" anchor="ctr"/>
+          <a:lstStyle/>
+          <a:p>
+            <a:pPr algn="ctr"/>
+          </a:p>
+        </p:txBody>
+      </p:sp>
+      <p:sp>
+        <p:nvSpPr>
+          <p:cNvPr id="19" name="TextBox 18"/>
+          <p:cNvSpPr txBox="1"/>
+          <p:nvPr/>
+        </p:nvSpPr>
+        <p:spPr>
+          <a:xfrm>
+            <a:off x="10094976" y="5212080"/>
+            <a:ext cx="1417320" cy="228600"/>
+          </a:xfrm>
+          <a:prstGeom prst="rect">
+            <a:avLst/>
+          </a:prstGeom>
+          <a:noFill/>
+        </p:spPr>
+        <p:txBody>
+          <a:bodyPr wrap="none">
+            <a:spAutoFit/>
+          </a:bodyPr>
+          <a:lstStyle/>
+          <a:p>
+            <a:pPr>
+              <a:defRPr sz="950" b="0">
+                <a:solidFill>
+                  <a:srgbClr val="17212B"/>
+                </a:solidFill>
+                <a:latin typeface="Arial"/>
+              </a:defRPr>
+            </a:pPr>
+            <a:r>
+              <a:t>Similarity</a:t>
+            </a:r>
+          </a:p>
+        </p:txBody>
+      </p:sp>
+      <p:sp>
+        <p:nvSpPr>
+          <p:cNvPr id="20" name="Oval 19"/>
+          <p:cNvSpPr/>
+          <p:nvPr/>
+        </p:nvSpPr>
+        <p:spPr>
+          <a:xfrm>
+            <a:off x="8275320" y="5650992"/>
+            <a:ext cx="109728" cy="109728"/>
+          </a:xfrm>
+          <a:prstGeom prst="ellipse">
+            <a:avLst/>
+          </a:prstGeom>
+          <a:solidFill>
+            <a:srgbClr val="B58CFF"/>
+          </a:solidFill>
+          <a:ln>
+            <a:solidFill>
+              <a:srgbClr val="B58CFF"/>
+            </a:solidFill>
+          </a:ln>
+        </p:spPr>
+        <p:style>
+          <a:lnRef idx="1">
+            <a:schemeClr val="accent1"/>
+          </a:lnRef>
+          <a:fillRef idx="3">
+            <a:schemeClr val="accent1"/>
+          </a:fillRef>
+          <a:effectRef idx="2">
+            <a:schemeClr val="accent1"/>
+          </a:effectRef>
+          <a:fontRef idx="minor">
+            <a:schemeClr val="lt1"/>
+          </a:fontRef>
+        </p:style>
+        <p:txBody>
+          <a:bodyPr rtlCol="0" anchor="ctr"/>
+          <a:lstStyle/>
+          <a:p>
+            <a:pPr algn="ctr"/>
+          </a:p>
+        </p:txBody>
+      </p:sp>
+      <p:sp>
+        <p:nvSpPr>
+          <p:cNvPr id="21" name="TextBox 20"/>
+          <p:cNvSpPr txBox="1"/>
+          <p:nvPr/>
+        </p:nvSpPr>
+        <p:spPr>
+          <a:xfrm>
+            <a:off x="8430768" y="5596128"/>
+            <a:ext cx="1417320" cy="228600"/>
+          </a:xfrm>
+          <a:prstGeom prst="rect">
+            <a:avLst/>
+          </a:prstGeom>
+          <a:noFill/>
+        </p:spPr>
+        <p:txBody>
+          <a:bodyPr wrap="none">
+            <a:spAutoFit/>
+          </a:bodyPr>
+          <a:lstStyle/>
+          <a:p>
+            <a:pPr>
+              <a:defRPr sz="950" b="0">
+                <a:solidFill>
+                  <a:srgbClr val="17212B"/>
+                </a:solidFill>
+                <a:latin typeface="Arial"/>
+              </a:defRPr>
+            </a:pPr>
+            <a:r>
+              <a:t>Diversity</a:t>
+            </a:r>
+          </a:p>
+        </p:txBody>
+      </p:sp>
+      <p:sp>
+        <p:nvSpPr>
+          <p:cNvPr id="22" name="Oval 21"/>
+          <p:cNvSpPr/>
+          <p:nvPr/>
+        </p:nvSpPr>
+        <p:spPr>
+          <a:xfrm>
+            <a:off x="9939528" y="5650992"/>
+            <a:ext cx="109728" cy="109728"/>
+          </a:xfrm>
+          <a:prstGeom prst="ellipse">
+            <a:avLst/>
+          </a:prstGeom>
+          <a:solidFill>
+            <a:srgbClr val="FF8A65"/>
+          </a:solidFill>
+          <a:ln>
+            <a:solidFill>
+              <a:srgbClr val="FF8A65"/>
+            </a:solidFill>
+          </a:ln>
+        </p:spPr>
+        <p:style>
+          <a:lnRef idx="1">
+            <a:schemeClr val="accent1"/>
+          </a:lnRef>
+          <a:fillRef idx="3">
+            <a:schemeClr val="accent1"/>
+          </a:fillRef>
+          <a:effectRef idx="2">
+            <a:schemeClr val="accent1"/>
+          </a:effectRef>
+          <a:fontRef idx="minor">
+            <a:schemeClr val="lt1"/>
+          </a:fontRef>
+        </p:style>
+        <p:txBody>
+          <a:bodyPr rtlCol="0" anchor="ctr"/>
+          <a:lstStyle/>
+          <a:p>
+            <a:pPr algn="ctr"/>
+          </a:p>
+        </p:txBody>
+      </p:sp>
+      <p:sp>
+        <p:nvSpPr>
+          <p:cNvPr id="23" name="TextBox 22"/>
+          <p:cNvSpPr txBox="1"/>
+          <p:nvPr/>
+        </p:nvSpPr>
+        <p:spPr>
+          <a:xfrm>
+            <a:off x="10094976" y="5596128"/>
+            <a:ext cx="1417320" cy="228600"/>
+          </a:xfrm>
+          <a:prstGeom prst="rect">
+            <a:avLst/>
+          </a:prstGeom>
+          <a:noFill/>
+        </p:spPr>
+        <p:txBody>
+          <a:bodyPr wrap="none">
+            <a:spAutoFit/>
+          </a:bodyPr>
+          <a:lstStyle/>
+          <a:p>
+            <a:pPr>
+              <a:defRPr sz="950" b="0">
+                <a:solidFill>
+                  <a:srgbClr val="17212B"/>
+                </a:solidFill>
+                <a:latin typeface="Arial"/>
+              </a:defRPr>
+            </a:pPr>
+            <a:r>
+              <a:t>ST Hard</a:t>
+            </a:r>
+          </a:p>
+        </p:txBody>
+      </p:sp>
+      <p:sp>
+        <p:nvSpPr>
+          <p:cNvPr id="24" name="TextBox 23"/>
+          <p:cNvSpPr txBox="1"/>
+          <p:nvPr/>
+        </p:nvSpPr>
+        <p:spPr>
+          <a:xfrm>
+            <a:off x="8275320" y="6099048"/>
+            <a:ext cx="3474720" cy="502920"/>
+          </a:xfrm>
+          <a:prstGeom prst="rect">
+            <a:avLst/>
+          </a:prstGeom>
+          <a:noFill/>
+        </p:spPr>
+        <p:txBody>
+          <a:bodyPr wrap="none">
+            <a:spAutoFit/>
+          </a:bodyPr>
+          <a:lstStyle/>
+          <a:p>
+            <a:pPr>
+              <a:defRPr sz="950" b="0">
+                <a:solidFill>
+                  <a:srgbClr val="526273"/>
+                </a:solidFill>
+                <a:latin typeface="Arial"/>
+              </a:defRPr>
+            </a:pPr>
+            <a:r>
+              <a:t>K includes the central target patch.</a:t>
+            </a:r>
+            <a:br/>
+            <a:r>
+              <a:t>Means across 8 patient-level folds.</a:t>
+            </a:r>
+          </a:p>
+        </p:txBody>
+      </p:sp>
     </p:spTree>
   </p:cSld>
   <p:clrMapOvr>

</xml_diff>